<commit_message>
Fix fence regex for nested JSON, add SLS comparison slide
Parsing fix: the code fence regex used non-greedy matching
({[\s\S]*?}) which captured only the first nested {} pair instead
of the full JSON response. Changed to greedy ({[\s\S]*}) so complex
rubrics responses with nested objects parse correctly.

Added slide 8 "How We Compare to SLS Short Answer FA" comparing
our prototype vs MOE SLS Feedback Assistant side-by-side.

Co-Authored-By: Claude Opus 4.6 (1M context) <noreply@anthropic.com>
</commit_message>
<xml_diff>
--- a/AI_Marking_Presentation.pptx
+++ b/AI_Marking_Presentation.pptx
@@ -12,6 +12,7 @@
     <p:sldId id="260" r:id="rId11"/>
     <p:sldId id="261" r:id="rId12"/>
     <p:sldId id="262" r:id="rId13"/>
+    <p:sldId id="264" r:id="rId15"/>
     <p:sldId id="263" r:id="rId14"/>
   </p:sldIdLst>
   <p:sldSz cx="12191695" cy="6858000" type="screen4x3"/>
@@ -6769,6 +6770,41 @@
           </a:p>
         </p:txBody>
       </p:sp>
+      <p:sp>
+        <p:nvSpPr>
+          <p:cNvPr id="20" name="TextBox 19"/>
+          <p:cNvSpPr txBox="1"/>
+          <p:nvPr/>
+        </p:nvSpPr>
+        <p:spPr>
+          <a:xfrm>
+            <a:off x="900000" y="5400000"/>
+            <a:ext cx="10440000" cy="540000"/>
+          </a:xfrm>
+          <a:prstGeom prst="rect">
+            <a:avLst/>
+          </a:prstGeom>
+          <a:noFill/>
+        </p:spPr>
+        <p:txBody>
+          <a:bodyPr wrap="square">
+            <a:spAutoFit/>
+          </a:bodyPr>
+          <a:lstStyle/>
+          <a:p>
+            <a:pPr algn="ctr"/>
+            <a:r>
+              <a:rPr sz="1100" b="1">
+                <a:solidFill>
+                  <a:srgbClr val="667EEA"/>
+                </a:solidFill>
+                <a:latin typeface="Calibri"/>
+              </a:rPr>
+              <a:t>All providers support both Short Answer and Rubrics/Essay marking modes with band-based evaluation.</a:t>
+            </a:r>
+          </a:p>
+        </p:txBody>
+      </p:sp>
     </p:spTree>
   </p:cSld>
   <p:clrMapOvr>
@@ -7808,6 +7844,1125 @@
             </a:pPr>
             <a:r>
               <a:t>Tip: Try the same script with different AI providers to compare marking quality!</a:t>
+            </a:r>
+          </a:p>
+        </p:txBody>
+      </p:sp>
+    </p:spTree>
+  </p:cSld>
+  <p:clrMapOvr>
+    <a:masterClrMapping/>
+  </p:clrMapOvr>
+</p:sld>
+</file>
+
+<file path=ppt/slides/slide9.xml><?xml version="1.0" encoding="utf-8"?>
+<p:sld xmlns:a="http://schemas.openxmlformats.org/drawingml/2006/main" xmlns:p="http://schemas.openxmlformats.org/presentationml/2006/main" xmlns:r="http://schemas.openxmlformats.org/officeDocument/2006/relationships">
+  <p:cSld>
+    <p:spTree>
+      <p:nvGrpSpPr>
+        <p:cNvPr id="1" name=""/>
+        <p:cNvGrpSpPr/>
+        <p:nvPr/>
+      </p:nvGrpSpPr>
+      <p:grpSpPr/>
+      <p:sp>
+        <p:nvSpPr>
+          <p:cNvPr id="2" name="Rectangle 1"/>
+          <p:cNvSpPr/>
+          <p:nvPr/>
+        </p:nvSpPr>
+        <p:spPr>
+          <a:xfrm>
+            <a:off x="0" y="0"/>
+            <a:ext cx="12191695" cy="72000"/>
+          </a:xfrm>
+          <a:prstGeom prst="rect">
+            <a:avLst/>
+          </a:prstGeom>
+          <a:solidFill>
+            <a:srgbClr val="667EEA"/>
+          </a:solidFill>
+          <a:ln>
+            <a:noFill/>
+          </a:ln>
+        </p:spPr>
+        <p:style>
+          <a:lnRef idx="1">
+            <a:schemeClr val="accent1"/>
+          </a:lnRef>
+          <a:fillRef idx="3">
+            <a:schemeClr val="accent1"/>
+          </a:fillRef>
+          <a:effectRef idx="2">
+            <a:schemeClr val="accent1"/>
+          </a:effectRef>
+          <a:fontRef idx="minor">
+            <a:schemeClr val="lt1"/>
+          </a:fontRef>
+        </p:style>
+        <p:txBody>
+          <a:bodyPr rtlCol="0" anchor="ctr"/>
+          <a:lstStyle/>
+          <a:p>
+            <a:pPr algn="ctr"/>
+          </a:p>
+        </p:txBody>
+      </p:sp>
+      <p:sp>
+        <p:nvSpPr>
+          <p:cNvPr id="3" name="TextBox 2"/>
+          <p:cNvSpPr txBox="1"/>
+          <p:nvPr/>
+        </p:nvSpPr>
+        <p:spPr>
+          <a:xfrm>
+            <a:off x="900000" y="432000"/>
+            <a:ext cx="10440000" cy="720000"/>
+          </a:xfrm>
+          <a:prstGeom prst="rect">
+            <a:avLst/>
+          </a:prstGeom>
+          <a:noFill/>
+        </p:spPr>
+        <p:txBody>
+          <a:bodyPr wrap="square">
+            <a:spAutoFit/>
+          </a:bodyPr>
+          <a:lstStyle/>
+          <a:p>
+            <a:pPr algn="l"/>
+            <a:r>
+              <a:rPr sz="2600" b="1">
+                <a:solidFill>
+                  <a:srgbClr val="2D2D2D"/>
+                </a:solidFill>
+                <a:latin typeface="Calibri"/>
+              </a:rPr>
+              <a:t>How We Compare to SLS Short Answer FA</a:t>
+            </a:r>
+          </a:p>
+        </p:txBody>
+      </p:sp>
+      <p:sp>
+        <p:nvSpPr>
+          <p:cNvPr id="4" name="TextBox 3"/>
+          <p:cNvSpPr txBox="1"/>
+          <p:nvPr/>
+        </p:nvSpPr>
+        <p:spPr>
+          <a:xfrm>
+            <a:off x="900000" y="1080000"/>
+            <a:ext cx="10440000" cy="360000"/>
+          </a:xfrm>
+          <a:prstGeom prst="rect">
+            <a:avLst/>
+          </a:prstGeom>
+          <a:noFill/>
+        </p:spPr>
+        <p:txBody>
+          <a:bodyPr wrap="square">
+            <a:spAutoFit/>
+          </a:bodyPr>
+          <a:lstStyle/>
+          <a:p>
+            <a:pPr algn="l"/>
+            <a:r>
+              <a:rPr sz="1200" b="0">
+                <a:solidFill>
+                  <a:srgbClr val="666666"/>
+                </a:solidFill>
+                <a:latin typeface="Calibri"/>
+              </a:rPr>
+              <a:t>Our prototype vs MOE Student Learning Space — Feedback Assistant</a:t>
+            </a:r>
+          </a:p>
+        </p:txBody>
+      </p:sp>
+      <p:sp>
+        <p:nvSpPr>
+          <p:cNvPr id="5" name="TextBox 4"/>
+          <p:cNvSpPr txBox="1"/>
+          <p:nvPr/>
+        </p:nvSpPr>
+        <p:spPr>
+          <a:xfrm>
+            <a:off x="900000" y="1512000"/>
+            <a:ext cx="4860000" cy="432000"/>
+          </a:xfrm>
+          <a:prstGeom prst="rect">
+            <a:avLst/>
+          </a:prstGeom>
+          <a:noFill/>
+        </p:spPr>
+        <p:txBody>
+          <a:bodyPr wrap="square">
+            <a:spAutoFit/>
+          </a:bodyPr>
+          <a:lstStyle/>
+          <a:p>
+            <a:pPr algn="ctr"/>
+            <a:r>
+              <a:rPr sz="1600" b="1">
+                <a:solidFill>
+                  <a:srgbClr val="667EEA"/>
+                </a:solidFill>
+                <a:latin typeface="Calibri"/>
+              </a:rPr>
+              <a:t>AI Marking Prototype</a:t>
+            </a:r>
+          </a:p>
+        </p:txBody>
+      </p:sp>
+      <p:sp>
+        <p:nvSpPr>
+          <p:cNvPr id="6" name="TextBox 5"/>
+          <p:cNvSpPr txBox="1"/>
+          <p:nvPr/>
+        </p:nvSpPr>
+        <p:spPr>
+          <a:xfrm>
+            <a:off x="900000" y="1980000"/>
+            <a:ext cx="4860000" cy="288000"/>
+          </a:xfrm>
+          <a:prstGeom prst="rect">
+            <a:avLst/>
+          </a:prstGeom>
+          <a:noFill/>
+        </p:spPr>
+        <p:txBody>
+          <a:bodyPr wrap="square">
+            <a:spAutoFit/>
+          </a:bodyPr>
+          <a:lstStyle/>
+          <a:p>
+            <a:pPr algn="l"/>
+            <a:r>
+              <a:rPr sz="1100" b="1">
+                <a:solidFill>
+                  <a:srgbClr val="28A745"/>
+                </a:solidFill>
+                <a:latin typeface="Calibri"/>
+              </a:rPr>
+              <a:t>✓  Vision-first</a:t>
+            </a:r>
+          </a:p>
+        </p:txBody>
+      </p:sp>
+      <p:sp>
+        <p:nvSpPr>
+          <p:cNvPr id="7" name="TextBox 6"/>
+          <p:cNvSpPr txBox="1"/>
+          <p:nvPr/>
+        </p:nvSpPr>
+        <p:spPr>
+          <a:xfrm>
+            <a:off x="1332000" y="2231999"/>
+            <a:ext cx="4428000" cy="251999"/>
+          </a:xfrm>
+          <a:prstGeom prst="rect">
+            <a:avLst/>
+          </a:prstGeom>
+          <a:noFill/>
+        </p:spPr>
+        <p:txBody>
+          <a:bodyPr wrap="square">
+            <a:spAutoFit/>
+          </a:bodyPr>
+          <a:lstStyle/>
+          <a:p>
+            <a:pPr algn="l"/>
+            <a:r>
+              <a:rPr sz="900" b="0">
+                <a:solidFill>
+                  <a:srgbClr val="666666"/>
+                </a:solidFill>
+                <a:latin typeface="Calibri"/>
+              </a:rPr>
+              <a:t>Designed for scanned handwritten scripts — photos of physical papers</a:t>
+            </a:r>
+          </a:p>
+        </p:txBody>
+      </p:sp>
+      <p:sp>
+        <p:nvSpPr>
+          <p:cNvPr id="8" name="TextBox 7"/>
+          <p:cNvSpPr txBox="1"/>
+          <p:nvPr/>
+        </p:nvSpPr>
+        <p:spPr>
+          <a:xfrm>
+            <a:off x="900000" y="2520000"/>
+            <a:ext cx="4860000" cy="288000"/>
+          </a:xfrm>
+          <a:prstGeom prst="rect">
+            <a:avLst/>
+          </a:prstGeom>
+          <a:noFill/>
+        </p:spPr>
+        <p:txBody>
+          <a:bodyPr wrap="square">
+            <a:spAutoFit/>
+          </a:bodyPr>
+          <a:lstStyle/>
+          <a:p>
+            <a:pPr algn="l"/>
+            <a:r>
+              <a:rPr sz="1100" b="1">
+                <a:solidFill>
+                  <a:srgbClr val="28A745"/>
+                </a:solidFill>
+                <a:latin typeface="Calibri"/>
+              </a:rPr>
+              <a:t>✓  Multi-provider</a:t>
+            </a:r>
+          </a:p>
+        </p:txBody>
+      </p:sp>
+      <p:sp>
+        <p:nvSpPr>
+          <p:cNvPr id="9" name="TextBox 8"/>
+          <p:cNvSpPr txBox="1"/>
+          <p:nvPr/>
+        </p:nvSpPr>
+        <p:spPr>
+          <a:xfrm>
+            <a:off x="1332000" y="2771999"/>
+            <a:ext cx="4428000" cy="251999"/>
+          </a:xfrm>
+          <a:prstGeom prst="rect">
+            <a:avLst/>
+          </a:prstGeom>
+          <a:noFill/>
+        </p:spPr>
+        <p:txBody>
+          <a:bodyPr wrap="square">
+            <a:spAutoFit/>
+          </a:bodyPr>
+          <a:lstStyle/>
+          <a:p>
+            <a:pPr algn="l"/>
+            <a:r>
+              <a:rPr sz="900" b="0">
+                <a:solidFill>
+                  <a:srgbClr val="666666"/>
+                </a:solidFill>
+                <a:latin typeface="Calibri"/>
+              </a:rPr>
+              <a:t>Compare Claude, GPT, Qwen side-by-side on the same script</a:t>
+            </a:r>
+          </a:p>
+        </p:txBody>
+      </p:sp>
+      <p:sp>
+        <p:nvSpPr>
+          <p:cNvPr id="10" name="TextBox 9"/>
+          <p:cNvSpPr txBox="1"/>
+          <p:nvPr/>
+        </p:nvSpPr>
+        <p:spPr>
+          <a:xfrm>
+            <a:off x="900000" y="3060000"/>
+            <a:ext cx="4860000" cy="288000"/>
+          </a:xfrm>
+          <a:prstGeom prst="rect">
+            <a:avLst/>
+          </a:prstGeom>
+          <a:noFill/>
+        </p:spPr>
+        <p:txBody>
+          <a:bodyPr wrap="square">
+            <a:spAutoFit/>
+          </a:bodyPr>
+          <a:lstStyle/>
+          <a:p>
+            <a:pPr algn="l"/>
+            <a:r>
+              <a:rPr sz="1100" b="1">
+                <a:solidFill>
+                  <a:srgbClr val="28A745"/>
+                </a:solidFill>
+                <a:latin typeface="Calibri"/>
+              </a:rPr>
+              <a:t>✓  Whole-paper marking</a:t>
+            </a:r>
+          </a:p>
+        </p:txBody>
+      </p:sp>
+      <p:sp>
+        <p:nvSpPr>
+          <p:cNvPr id="11" name="TextBox 10"/>
+          <p:cNvSpPr txBox="1"/>
+          <p:nvPr/>
+        </p:nvSpPr>
+        <p:spPr>
+          <a:xfrm>
+            <a:off x="1332000" y="3311999"/>
+            <a:ext cx="4428000" cy="251999"/>
+          </a:xfrm>
+          <a:prstGeom prst="rect">
+            <a:avLst/>
+          </a:prstGeom>
+          <a:noFill/>
+        </p:spPr>
+        <p:txBody>
+          <a:bodyPr wrap="square">
+            <a:spAutoFit/>
+          </a:bodyPr>
+          <a:lstStyle/>
+          <a:p>
+            <a:pPr algn="l"/>
+            <a:r>
+              <a:rPr sz="900" b="0">
+                <a:solidFill>
+                  <a:srgbClr val="666666"/>
+                </a:solidFill>
+                <a:latin typeface="Calibri"/>
+              </a:rPr>
+              <a:t>Processes entire exam paper at once, not question by question</a:t>
+            </a:r>
+          </a:p>
+        </p:txBody>
+      </p:sp>
+      <p:sp>
+        <p:nvSpPr>
+          <p:cNvPr id="12" name="TextBox 11"/>
+          <p:cNvSpPr txBox="1"/>
+          <p:nvPr/>
+        </p:nvSpPr>
+        <p:spPr>
+          <a:xfrm>
+            <a:off x="900000" y="3600000"/>
+            <a:ext cx="4860000" cy="288000"/>
+          </a:xfrm>
+          <a:prstGeom prst="rect">
+            <a:avLst/>
+          </a:prstGeom>
+          <a:noFill/>
+        </p:spPr>
+        <p:txBody>
+          <a:bodyPr wrap="square">
+            <a:spAutoFit/>
+          </a:bodyPr>
+          <a:lstStyle/>
+          <a:p>
+            <a:pPr algn="l"/>
+            <a:r>
+              <a:rPr sz="1100" b="1">
+                <a:solidFill>
+                  <a:srgbClr val="28A745"/>
+                </a:solidFill>
+                <a:latin typeface="Calibri"/>
+              </a:rPr>
+              <a:t>✓  Math support</a:t>
+            </a:r>
+          </a:p>
+        </p:txBody>
+      </p:sp>
+      <p:sp>
+        <p:nvSpPr>
+          <p:cNvPr id="13" name="TextBox 12"/>
+          <p:cNvSpPr txBox="1"/>
+          <p:nvPr/>
+        </p:nvSpPr>
+        <p:spPr>
+          <a:xfrm>
+            <a:off x="1332000" y="3851999"/>
+            <a:ext cx="4428000" cy="251999"/>
+          </a:xfrm>
+          <a:prstGeom prst="rect">
+            <a:avLst/>
+          </a:prstGeom>
+          <a:noFill/>
+        </p:spPr>
+        <p:txBody>
+          <a:bodyPr wrap="square">
+            <a:spAutoFit/>
+          </a:bodyPr>
+          <a:lstStyle/>
+          <a:p>
+            <a:pPr algn="l"/>
+            <a:r>
+              <a:rPr sz="900" b="0">
+                <a:solidFill>
+                  <a:srgbClr val="666666"/>
+                </a:solidFill>
+                <a:latin typeface="Calibri"/>
+              </a:rPr>
+              <a:t>Handles mathematical notation — SLS FA explicitly cannot</a:t>
+            </a:r>
+          </a:p>
+        </p:txBody>
+      </p:sp>
+      <p:sp>
+        <p:nvSpPr>
+          <p:cNvPr id="14" name="TextBox 13"/>
+          <p:cNvSpPr txBox="1"/>
+          <p:nvPr/>
+        </p:nvSpPr>
+        <p:spPr>
+          <a:xfrm>
+            <a:off x="900000" y="4140000"/>
+            <a:ext cx="4860000" cy="288000"/>
+          </a:xfrm>
+          <a:prstGeom prst="rect">
+            <a:avLst/>
+          </a:prstGeom>
+          <a:noFill/>
+        </p:spPr>
+        <p:txBody>
+          <a:bodyPr wrap="square">
+            <a:spAutoFit/>
+          </a:bodyPr>
+          <a:lstStyle/>
+          <a:p>
+            <a:pPr algn="l"/>
+            <a:r>
+              <a:rPr sz="1100" b="1">
+                <a:solidFill>
+                  <a:srgbClr val="28A745"/>
+                </a:solidFill>
+                <a:latin typeface="Calibri"/>
+              </a:rPr>
+              <a:t>✓  Rubrics with bands</a:t>
+            </a:r>
+          </a:p>
+        </p:txBody>
+      </p:sp>
+      <p:sp>
+        <p:nvSpPr>
+          <p:cNvPr id="15" name="TextBox 14"/>
+          <p:cNvSpPr txBox="1"/>
+          <p:nvPr/>
+        </p:nvSpPr>
+        <p:spPr>
+          <a:xfrm>
+            <a:off x="1332000" y="4391999"/>
+            <a:ext cx="4428000" cy="251999"/>
+          </a:xfrm>
+          <a:prstGeom prst="rect">
+            <a:avLst/>
+          </a:prstGeom>
+          <a:noFill/>
+        </p:spPr>
+        <p:txBody>
+          <a:bodyPr wrap="square">
+            <a:spAutoFit/>
+          </a:bodyPr>
+          <a:lstStyle/>
+          <a:p>
+            <a:pPr algn="l"/>
+            <a:r>
+              <a:rPr sz="900" b="0">
+                <a:solidFill>
+                  <a:srgbClr val="666666"/>
+                </a:solidFill>
+                <a:latin typeface="Calibri"/>
+              </a:rPr>
+              <a:t>Reads rubric tables, places student in correct band, line-by-line errors</a:t>
+            </a:r>
+          </a:p>
+        </p:txBody>
+      </p:sp>
+      <p:sp>
+        <p:nvSpPr>
+          <p:cNvPr id="16" name="TextBox 15"/>
+          <p:cNvSpPr txBox="1"/>
+          <p:nvPr/>
+        </p:nvSpPr>
+        <p:spPr>
+          <a:xfrm>
+            <a:off x="900000" y="4680000"/>
+            <a:ext cx="4860000" cy="288000"/>
+          </a:xfrm>
+          <a:prstGeom prst="rect">
+            <a:avLst/>
+          </a:prstGeom>
+          <a:noFill/>
+        </p:spPr>
+        <p:txBody>
+          <a:bodyPr wrap="square">
+            <a:spAutoFit/>
+          </a:bodyPr>
+          <a:lstStyle/>
+          <a:p>
+            <a:pPr algn="l"/>
+            <a:r>
+              <a:rPr sz="1100" b="1">
+                <a:solidFill>
+                  <a:srgbClr val="28A745"/>
+                </a:solidFill>
+                <a:latin typeface="Calibri"/>
+              </a:rPr>
+              <a:t>✓  No platform lock-in</a:t>
+            </a:r>
+          </a:p>
+        </p:txBody>
+      </p:sp>
+      <p:sp>
+        <p:nvSpPr>
+          <p:cNvPr id="17" name="TextBox 16"/>
+          <p:cNvSpPr txBox="1"/>
+          <p:nvPr/>
+        </p:nvSpPr>
+        <p:spPr>
+          <a:xfrm>
+            <a:off x="1332000" y="4931999"/>
+            <a:ext cx="4428000" cy="251999"/>
+          </a:xfrm>
+          <a:prstGeom prst="rect">
+            <a:avLst/>
+          </a:prstGeom>
+          <a:noFill/>
+        </p:spPr>
+        <p:txBody>
+          <a:bodyPr wrap="square">
+            <a:spAutoFit/>
+          </a:bodyPr>
+          <a:lstStyle/>
+          <a:p>
+            <a:pPr algn="l"/>
+            <a:r>
+              <a:rPr sz="900" b="0">
+                <a:solidFill>
+                  <a:srgbClr val="666666"/>
+                </a:solidFill>
+                <a:latin typeface="Calibri"/>
+              </a:rPr>
+              <a:t>Works independently of any LMS</a:t>
+            </a:r>
+          </a:p>
+        </p:txBody>
+      </p:sp>
+      <p:sp>
+        <p:nvSpPr>
+          <p:cNvPr id="18" name="TextBox 17"/>
+          <p:cNvSpPr txBox="1"/>
+          <p:nvPr/>
+        </p:nvSpPr>
+        <p:spPr>
+          <a:xfrm>
+            <a:off x="6300000" y="1512000"/>
+            <a:ext cx="4860000" cy="432000"/>
+          </a:xfrm>
+          <a:prstGeom prst="rect">
+            <a:avLst/>
+          </a:prstGeom>
+          <a:noFill/>
+        </p:spPr>
+        <p:txBody>
+          <a:bodyPr wrap="square">
+            <a:spAutoFit/>
+          </a:bodyPr>
+          <a:lstStyle/>
+          <a:p>
+            <a:pPr algn="ctr"/>
+            <a:r>
+              <a:rPr sz="1600" b="1">
+                <a:solidFill>
+                  <a:srgbClr val="667EEA"/>
+                </a:solidFill>
+                <a:latin typeface="Calibri"/>
+              </a:rPr>
+              <a:t>SLS Feedback Assistant</a:t>
+            </a:r>
+          </a:p>
+        </p:txBody>
+      </p:sp>
+      <p:sp>
+        <p:nvSpPr>
+          <p:cNvPr id="19" name="TextBox 18"/>
+          <p:cNvSpPr txBox="1"/>
+          <p:nvPr/>
+        </p:nvSpPr>
+        <p:spPr>
+          <a:xfrm>
+            <a:off x="6300000" y="1980000"/>
+            <a:ext cx="4860000" cy="288000"/>
+          </a:xfrm>
+          <a:prstGeom prst="rect">
+            <a:avLst/>
+          </a:prstGeom>
+          <a:noFill/>
+        </p:spPr>
+        <p:txBody>
+          <a:bodyPr wrap="square">
+            <a:spAutoFit/>
+          </a:bodyPr>
+          <a:lstStyle/>
+          <a:p>
+            <a:pPr algn="l"/>
+            <a:r>
+              <a:rPr sz="1100" b="1">
+                <a:solidFill>
+                  <a:srgbClr val="667EEA"/>
+                </a:solidFill>
+                <a:latin typeface="Calibri"/>
+              </a:rPr>
+              <a:t>✓  Integrated workflow</a:t>
+            </a:r>
+          </a:p>
+        </p:txBody>
+      </p:sp>
+      <p:sp>
+        <p:nvSpPr>
+          <p:cNvPr id="20" name="TextBox 19"/>
+          <p:cNvSpPr txBox="1"/>
+          <p:nvPr/>
+        </p:nvSpPr>
+        <p:spPr>
+          <a:xfrm>
+            <a:off x="6732000" y="2231999"/>
+            <a:ext cx="4428000" cy="251999"/>
+          </a:xfrm>
+          <a:prstGeom prst="rect">
+            <a:avLst/>
+          </a:prstGeom>
+          <a:noFill/>
+        </p:spPr>
+        <p:txBody>
+          <a:bodyPr wrap="square">
+            <a:spAutoFit/>
+          </a:bodyPr>
+          <a:lstStyle/>
+          <a:p>
+            <a:pPr algn="l"/>
+            <a:r>
+              <a:rPr sz="900" b="0">
+                <a:solidFill>
+                  <a:srgbClr val="666666"/>
+                </a:solidFill>
+                <a:latin typeface="Calibri"/>
+              </a:rPr>
+              <a:t>Marks flow directly to students within SLS — no manual sharing</a:t>
+            </a:r>
+          </a:p>
+        </p:txBody>
+      </p:sp>
+      <p:sp>
+        <p:nvSpPr>
+          <p:cNvPr id="21" name="TextBox 20"/>
+          <p:cNvSpPr txBox="1"/>
+          <p:nvPr/>
+        </p:nvSpPr>
+        <p:spPr>
+          <a:xfrm>
+            <a:off x="6300000" y="2520000"/>
+            <a:ext cx="4860000" cy="288000"/>
+          </a:xfrm>
+          <a:prstGeom prst="rect">
+            <a:avLst/>
+          </a:prstGeom>
+          <a:noFill/>
+        </p:spPr>
+        <p:txBody>
+          <a:bodyPr wrap="square">
+            <a:spAutoFit/>
+          </a:bodyPr>
+          <a:lstStyle/>
+          <a:p>
+            <a:pPr algn="l"/>
+            <a:r>
+              <a:rPr sz="1100" b="1">
+                <a:solidFill>
+                  <a:srgbClr val="667EEA"/>
+                </a:solidFill>
+                <a:latin typeface="Calibri"/>
+              </a:rPr>
+              <a:t>✓  Class-scale</a:t>
+            </a:r>
+          </a:p>
+        </p:txBody>
+      </p:sp>
+      <p:sp>
+        <p:nvSpPr>
+          <p:cNvPr id="22" name="TextBox 21"/>
+          <p:cNvSpPr txBox="1"/>
+          <p:nvPr/>
+        </p:nvSpPr>
+        <p:spPr>
+          <a:xfrm>
+            <a:off x="6732000" y="2771999"/>
+            <a:ext cx="4428000" cy="251999"/>
+          </a:xfrm>
+          <a:prstGeom prst="rect">
+            <a:avLst/>
+          </a:prstGeom>
+          <a:noFill/>
+        </p:spPr>
+        <p:txBody>
+          <a:bodyPr wrap="square">
+            <a:spAutoFit/>
+          </a:bodyPr>
+          <a:lstStyle/>
+          <a:p>
+            <a:pPr algn="l"/>
+            <a:r>
+              <a:rPr sz="900" b="0">
+                <a:solidFill>
+                  <a:srgbClr val="666666"/>
+                </a:solidFill>
+                <a:latin typeface="Calibri"/>
+              </a:rPr>
+              <a:t>Handles entire class rosters natively from assignment</a:t>
+            </a:r>
+          </a:p>
+        </p:txBody>
+      </p:sp>
+      <p:sp>
+        <p:nvSpPr>
+          <p:cNvPr id="23" name="TextBox 22"/>
+          <p:cNvSpPr txBox="1"/>
+          <p:nvPr/>
+        </p:nvSpPr>
+        <p:spPr>
+          <a:xfrm>
+            <a:off x="6300000" y="3060000"/>
+            <a:ext cx="4860000" cy="288000"/>
+          </a:xfrm>
+          <a:prstGeom prst="rect">
+            <a:avLst/>
+          </a:prstGeom>
+          <a:noFill/>
+        </p:spPr>
+        <p:txBody>
+          <a:bodyPr wrap="square">
+            <a:spAutoFit/>
+          </a:bodyPr>
+          <a:lstStyle/>
+          <a:p>
+            <a:pPr algn="l"/>
+            <a:r>
+              <a:rPr sz="1100" b="1">
+                <a:solidFill>
+                  <a:srgbClr val="667EEA"/>
+                </a:solidFill>
+                <a:latin typeface="Calibri"/>
+              </a:rPr>
+              <a:t>✓  Built-in rubric builder</a:t>
+            </a:r>
+          </a:p>
+        </p:txBody>
+      </p:sp>
+      <p:sp>
+        <p:nvSpPr>
+          <p:cNvPr id="24" name="TextBox 23"/>
+          <p:cNvSpPr txBox="1"/>
+          <p:nvPr/>
+        </p:nvSpPr>
+        <p:spPr>
+          <a:xfrm>
+            <a:off x="6732000" y="3311999"/>
+            <a:ext cx="4428000" cy="251999"/>
+          </a:xfrm>
+          <a:prstGeom prst="rect">
+            <a:avLst/>
+          </a:prstGeom>
+          <a:noFill/>
+        </p:spPr>
+        <p:txBody>
+          <a:bodyPr wrap="square">
+            <a:spAutoFit/>
+          </a:bodyPr>
+          <a:lstStyle/>
+          <a:p>
+            <a:pPr algn="l"/>
+            <a:r>
+              <a:rPr sz="900" b="0">
+                <a:solidFill>
+                  <a:srgbClr val="666666"/>
+                </a:solidFill>
+                <a:latin typeface="Calibri"/>
+              </a:rPr>
+              <a:t>Create rubrics manually, from library, or AI-generated</a:t>
+            </a:r>
+          </a:p>
+        </p:txBody>
+      </p:sp>
+      <p:sp>
+        <p:nvSpPr>
+          <p:cNvPr id="25" name="TextBox 24"/>
+          <p:cNvSpPr txBox="1"/>
+          <p:nvPr/>
+        </p:nvSpPr>
+        <p:spPr>
+          <a:xfrm>
+            <a:off x="6300000" y="3600000"/>
+            <a:ext cx="4860000" cy="288000"/>
+          </a:xfrm>
+          <a:prstGeom prst="rect">
+            <a:avLst/>
+          </a:prstGeom>
+          <a:noFill/>
+        </p:spPr>
+        <p:txBody>
+          <a:bodyPr wrap="square">
+            <a:spAutoFit/>
+          </a:bodyPr>
+          <a:lstStyle/>
+          <a:p>
+            <a:pPr algn="l"/>
+            <a:r>
+              <a:rPr sz="1100" b="1">
+                <a:solidFill>
+                  <a:srgbClr val="667EEA"/>
+                </a:solidFill>
+                <a:latin typeface="Calibri"/>
+              </a:rPr>
+              <a:t>✓  Edit-in-place</a:t>
+            </a:r>
+          </a:p>
+        </p:txBody>
+      </p:sp>
+      <p:sp>
+        <p:nvSpPr>
+          <p:cNvPr id="26" name="TextBox 25"/>
+          <p:cNvSpPr txBox="1"/>
+          <p:nvPr/>
+        </p:nvSpPr>
+        <p:spPr>
+          <a:xfrm>
+            <a:off x="6732000" y="3851999"/>
+            <a:ext cx="4428000" cy="251999"/>
+          </a:xfrm>
+          <a:prstGeom prst="rect">
+            <a:avLst/>
+          </a:prstGeom>
+          <a:noFill/>
+        </p:spPr>
+        <p:txBody>
+          <a:bodyPr wrap="square">
+            <a:spAutoFit/>
+          </a:bodyPr>
+          <a:lstStyle/>
+          <a:p>
+            <a:pPr algn="l"/>
+            <a:r>
+              <a:rPr sz="900" b="0">
+                <a:solidFill>
+                  <a:srgbClr val="666666"/>
+                </a:solidFill>
+                <a:latin typeface="Calibri"/>
+              </a:rPr>
+              <a:t>Teachers adjust marks and feedback before students see them</a:t>
+            </a:r>
+          </a:p>
+        </p:txBody>
+      </p:sp>
+      <p:sp>
+        <p:nvSpPr>
+          <p:cNvPr id="27" name="TextBox 26"/>
+          <p:cNvSpPr txBox="1"/>
+          <p:nvPr/>
+        </p:nvSpPr>
+        <p:spPr>
+          <a:xfrm>
+            <a:off x="6300000" y="4140000"/>
+            <a:ext cx="4860000" cy="288000"/>
+          </a:xfrm>
+          <a:prstGeom prst="rect">
+            <a:avLst/>
+          </a:prstGeom>
+          <a:noFill/>
+        </p:spPr>
+        <p:txBody>
+          <a:bodyPr wrap="square">
+            <a:spAutoFit/>
+          </a:bodyPr>
+          <a:lstStyle/>
+          <a:p>
+            <a:pPr algn="l"/>
+            <a:r>
+              <a:rPr sz="1100" b="1">
+                <a:solidFill>
+                  <a:srgbClr val="667EEA"/>
+                </a:solidFill>
+                <a:latin typeface="Calibri"/>
+              </a:rPr>
+              <a:t>✓  Typed responses</a:t>
+            </a:r>
+          </a:p>
+        </p:txBody>
+      </p:sp>
+      <p:sp>
+        <p:nvSpPr>
+          <p:cNvPr id="28" name="TextBox 27"/>
+          <p:cNvSpPr txBox="1"/>
+          <p:nvPr/>
+        </p:nvSpPr>
+        <p:spPr>
+          <a:xfrm>
+            <a:off x="6732000" y="4391999"/>
+            <a:ext cx="4428000" cy="251999"/>
+          </a:xfrm>
+          <a:prstGeom prst="rect">
+            <a:avLst/>
+          </a:prstGeom>
+          <a:noFill/>
+        </p:spPr>
+        <p:txBody>
+          <a:bodyPr wrap="square">
+            <a:spAutoFit/>
+          </a:bodyPr>
+          <a:lstStyle/>
+          <a:p>
+            <a:pPr algn="l"/>
+            <a:r>
+              <a:rPr sz="900" b="0">
+                <a:solidFill>
+                  <a:srgbClr val="666666"/>
+                </a:solidFill>
+                <a:latin typeface="Calibri"/>
+              </a:rPr>
+              <a:t>Optimised for typed text input within the platform</a:t>
+            </a:r>
+          </a:p>
+        </p:txBody>
+      </p:sp>
+      <p:sp>
+        <p:nvSpPr>
+          <p:cNvPr id="29" name="TextBox 28"/>
+          <p:cNvSpPr txBox="1"/>
+          <p:nvPr/>
+        </p:nvSpPr>
+        <p:spPr>
+          <a:xfrm>
+            <a:off x="6300000" y="4680000"/>
+            <a:ext cx="4860000" cy="288000"/>
+          </a:xfrm>
+          <a:prstGeom prst="rect">
+            <a:avLst/>
+          </a:prstGeom>
+          <a:noFill/>
+        </p:spPr>
+        <p:txBody>
+          <a:bodyPr wrap="square">
+            <a:spAutoFit/>
+          </a:bodyPr>
+          <a:lstStyle/>
+          <a:p>
+            <a:pPr algn="l"/>
+            <a:r>
+              <a:rPr sz="1100" b="1">
+                <a:solidFill>
+                  <a:srgbClr val="667EEA"/>
+                </a:solidFill>
+                <a:latin typeface="Calibri"/>
+              </a:rPr>
+              <a:t>✓  Per-question</a:t>
+            </a:r>
+          </a:p>
+        </p:txBody>
+      </p:sp>
+      <p:sp>
+        <p:nvSpPr>
+          <p:cNvPr id="30" name="TextBox 29"/>
+          <p:cNvSpPr txBox="1"/>
+          <p:nvPr/>
+        </p:nvSpPr>
+        <p:spPr>
+          <a:xfrm>
+            <a:off x="6732000" y="4931999"/>
+            <a:ext cx="4428000" cy="251999"/>
+          </a:xfrm>
+          <a:prstGeom prst="rect">
+            <a:avLst/>
+          </a:prstGeom>
+          <a:noFill/>
+        </p:spPr>
+        <p:txBody>
+          <a:bodyPr wrap="square">
+            <a:spAutoFit/>
+          </a:bodyPr>
+          <a:lstStyle/>
+          <a:p>
+            <a:pPr algn="l"/>
+            <a:r>
+              <a:rPr sz="900" b="0">
+                <a:solidFill>
+                  <a:srgbClr val="666666"/>
+                </a:solidFill>
+                <a:latin typeface="Calibri"/>
+              </a:rPr>
+              <a:t>Marks one question at a time with tailored mark schemes</a:t>
+            </a:r>
+          </a:p>
+        </p:txBody>
+      </p:sp>
+      <p:sp>
+        <p:nvSpPr>
+          <p:cNvPr id="31" name="Rectangle 30"/>
+          <p:cNvSpPr/>
+          <p:nvPr/>
+        </p:nvSpPr>
+        <p:spPr>
+          <a:xfrm>
+            <a:off x="5940000" y="1620000"/>
+            <a:ext cx="18000" cy="3600000"/>
+          </a:xfrm>
+          <a:prstGeom prst="rect">
+            <a:avLst/>
+          </a:prstGeom>
+          <a:solidFill>
+            <a:srgbClr val="DDDDDD"/>
+          </a:solidFill>
+          <a:ln>
+            <a:noFill/>
+          </a:ln>
+        </p:spPr>
+        <p:style>
+          <a:lnRef idx="1">
+            <a:schemeClr val="accent1"/>
+          </a:lnRef>
+          <a:fillRef idx="3">
+            <a:schemeClr val="accent1"/>
+          </a:fillRef>
+          <a:effectRef idx="2">
+            <a:schemeClr val="accent1"/>
+          </a:effectRef>
+          <a:fontRef idx="minor">
+            <a:schemeClr val="lt1"/>
+          </a:fontRef>
+        </p:style>
+        <p:txBody>
+          <a:bodyPr rtlCol="0" anchor="ctr"/>
+          <a:lstStyle/>
+          <a:p>
+            <a:pPr algn="ctr"/>
+          </a:p>
+        </p:txBody>
+      </p:sp>
+      <p:sp>
+        <p:nvSpPr>
+          <p:cNvPr id="32" name="TextBox 31"/>
+          <p:cNvSpPr txBox="1"/>
+          <p:nvPr/>
+        </p:nvSpPr>
+        <p:spPr>
+          <a:xfrm>
+            <a:off x="900000" y="5580000"/>
+            <a:ext cx="10440000" cy="540000"/>
+          </a:xfrm>
+          <a:prstGeom prst="rect">
+            <a:avLst/>
+          </a:prstGeom>
+          <a:noFill/>
+        </p:spPr>
+        <p:txBody>
+          <a:bodyPr wrap="square">
+            <a:spAutoFit/>
+          </a:bodyPr>
+          <a:lstStyle/>
+          <a:p>
+            <a:pPr algn="ctr"/>
+            <a:r>
+              <a:rPr sz="1100" b="1">
+                <a:solidFill>
+                  <a:srgbClr val="2D2D2D"/>
+                </a:solidFill>
+                <a:latin typeface="Calibri"/>
+              </a:rPr>
+              <a:t>Key difference: SLS FA is not suitable for mathematical computation. Our prototype handles math, handwriting, and scanned papers natively.</a:t>
             </a:r>
           </a:p>
         </p:txBody>

</xml_diff>

<commit_message>
docs: add planning docs for dept mode, insights, unified assignment page; update presentation
Co-Authored-By: Claude Opus 4.7 (1M context) <noreply@anthropic.com>
</commit_message>
<xml_diff>
--- a/AI_Marking_Presentation.pptx
+++ b/AI_Marking_Presentation.pptx
@@ -5,17 +5,17 @@
     <p:sldMasterId id="2147483648" r:id="rId1"/>
   </p:sldMasterIdLst>
   <p:sldIdLst>
-    <p:sldId id="256" r:id="rId7"/>
-    <p:sldId id="257" r:id="rId8"/>
-    <p:sldId id="258" r:id="rId9"/>
-    <p:sldId id="259" r:id="rId10"/>
-    <p:sldId id="260" r:id="rId11"/>
-    <p:sldId id="261" r:id="rId12"/>
-    <p:sldId id="262" r:id="rId13"/>
-    <p:sldId id="264" r:id="rId15"/>
-    <p:sldId id="263" r:id="rId14"/>
+    <p:sldId id="256" r:id="rId2"/>
+    <p:sldId id="257" r:id="rId3"/>
+    <p:sldId id="258" r:id="rId4"/>
+    <p:sldId id="259" r:id="rId5"/>
+    <p:sldId id="260" r:id="rId6"/>
+    <p:sldId id="261" r:id="rId7"/>
+    <p:sldId id="262" r:id="rId8"/>
+    <p:sldId id="264" r:id="rId9"/>
+    <p:sldId id="263" r:id="rId10"/>
   </p:sldIdLst>
-  <p:sldSz cx="12191695" cy="6858000" type="screen4x3"/>
+  <p:sldSz cx="12192000" cy="6858000"/>
   <p:notesSz cx="6858000" cy="9144000"/>
   <p:defaultTextStyle>
     <a:defPPr>
@@ -112,6 +112,22 @@
       </a:defRPr>
     </a:lvl9pPr>
   </p:defaultTextStyle>
+  <p:extLst>
+    <p:ext uri="{EFAFB233-063F-42B5-8137-9DF3F51BA10A}">
+      <p15:sldGuideLst xmlns:p15="http://schemas.microsoft.com/office/powerpoint/2012/main">
+        <p15:guide id="1" orient="horz" pos="2160">
+          <p15:clr>
+            <a:srgbClr val="A4A3A4"/>
+          </p15:clr>
+        </p15:guide>
+        <p15:guide id="2" pos="2880">
+          <p15:clr>
+            <a:srgbClr val="A4A3A4"/>
+          </p15:clr>
+        </p15:guide>
+      </p15:sldGuideLst>
+    </p:ext>
+  </p:extLst>
 </p:presentation>
 </file>
 
@@ -153,10 +169,9 @@
           <a:lstStyle/>
           <a:p>
             <a:r>
-              <a:rPr lang="en-US" smtClean="0"/>
+              <a:rPr lang="en-US"/>
               <a:t>Click to edit Master title style</a:t>
             </a:r>
-            <a:endParaRPr lang="en-US"/>
           </a:p>
         </p:txBody>
       </p:sp>
@@ -272,10 +287,9 @@
           </a:lstStyle>
           <a:p>
             <a:r>
-              <a:rPr lang="en-US" smtClean="0"/>
+              <a:rPr lang="en-US"/>
               <a:t>Click to edit Master subtitle style</a:t>
             </a:r>
-            <a:endParaRPr lang="en-US"/>
           </a:p>
         </p:txBody>
       </p:sp>
@@ -296,7 +310,7 @@
           <a:p>
             <a:fld id="{5BCAD085-E8A6-8845-BD4E-CB4CCA059FC4}" type="datetimeFigureOut">
               <a:rPr lang="en-US" smtClean="0"/>
-              <a:t>1/27/13</a:t>
+              <a:t>4/8/26</a:t>
             </a:fld>
             <a:endParaRPr lang="en-US"/>
           </a:p>
@@ -390,10 +404,9 @@
           <a:lstStyle/>
           <a:p>
             <a:r>
-              <a:rPr lang="en-US" smtClean="0"/>
+              <a:rPr lang="en-US"/>
               <a:t>Click to edit Master title style</a:t>
             </a:r>
-            <a:endParaRPr lang="en-US"/>
           </a:p>
         </p:txBody>
       </p:sp>
@@ -414,38 +427,37 @@
           <a:p>
             <a:pPr lvl="0"/>
             <a:r>
-              <a:rPr lang="en-US" smtClean="0"/>
+              <a:rPr lang="en-US"/>
               <a:t>Click to edit Master text styles</a:t>
             </a:r>
           </a:p>
           <a:p>
             <a:pPr lvl="1"/>
             <a:r>
-              <a:rPr lang="en-US" smtClean="0"/>
+              <a:rPr lang="en-US"/>
               <a:t>Second level</a:t>
             </a:r>
           </a:p>
           <a:p>
             <a:pPr lvl="2"/>
             <a:r>
-              <a:rPr lang="en-US" smtClean="0"/>
+              <a:rPr lang="en-US"/>
               <a:t>Third level</a:t>
             </a:r>
           </a:p>
           <a:p>
             <a:pPr lvl="3"/>
             <a:r>
-              <a:rPr lang="en-US" smtClean="0"/>
+              <a:rPr lang="en-US"/>
               <a:t>Fourth level</a:t>
             </a:r>
           </a:p>
           <a:p>
             <a:pPr lvl="4"/>
             <a:r>
-              <a:rPr lang="en-US" smtClean="0"/>
+              <a:rPr lang="en-US"/>
               <a:t>Fifth level</a:t>
             </a:r>
-            <a:endParaRPr lang="en-US"/>
           </a:p>
         </p:txBody>
       </p:sp>
@@ -466,7 +478,7 @@
           <a:p>
             <a:fld id="{5BCAD085-E8A6-8845-BD4E-CB4CCA059FC4}" type="datetimeFigureOut">
               <a:rPr lang="en-US" smtClean="0"/>
-              <a:t>1/27/13</a:t>
+              <a:t>4/8/26</a:t>
             </a:fld>
             <a:endParaRPr lang="en-US"/>
           </a:p>
@@ -565,10 +577,9 @@
           <a:lstStyle/>
           <a:p>
             <a:r>
-              <a:rPr lang="en-US" smtClean="0"/>
+              <a:rPr lang="en-US"/>
               <a:t>Click to edit Master title style</a:t>
             </a:r>
-            <a:endParaRPr lang="en-US"/>
           </a:p>
         </p:txBody>
       </p:sp>
@@ -594,38 +605,37 @@
           <a:p>
             <a:pPr lvl="0"/>
             <a:r>
-              <a:rPr lang="en-US" smtClean="0"/>
+              <a:rPr lang="en-US"/>
               <a:t>Click to edit Master text styles</a:t>
             </a:r>
           </a:p>
           <a:p>
             <a:pPr lvl="1"/>
             <a:r>
-              <a:rPr lang="en-US" smtClean="0"/>
+              <a:rPr lang="en-US"/>
               <a:t>Second level</a:t>
             </a:r>
           </a:p>
           <a:p>
             <a:pPr lvl="2"/>
             <a:r>
-              <a:rPr lang="en-US" smtClean="0"/>
+              <a:rPr lang="en-US"/>
               <a:t>Third level</a:t>
             </a:r>
           </a:p>
           <a:p>
             <a:pPr lvl="3"/>
             <a:r>
-              <a:rPr lang="en-US" smtClean="0"/>
+              <a:rPr lang="en-US"/>
               <a:t>Fourth level</a:t>
             </a:r>
           </a:p>
           <a:p>
             <a:pPr lvl="4"/>
             <a:r>
-              <a:rPr lang="en-US" smtClean="0"/>
+              <a:rPr lang="en-US"/>
               <a:t>Fifth level</a:t>
             </a:r>
-            <a:endParaRPr lang="en-US"/>
           </a:p>
         </p:txBody>
       </p:sp>
@@ -646,7 +656,7 @@
           <a:p>
             <a:fld id="{5BCAD085-E8A6-8845-BD4E-CB4CCA059FC4}" type="datetimeFigureOut">
               <a:rPr lang="en-US" smtClean="0"/>
-              <a:t>1/27/13</a:t>
+              <a:t>4/8/26</a:t>
             </a:fld>
             <a:endParaRPr lang="en-US"/>
           </a:p>
@@ -740,10 +750,9 @@
           <a:lstStyle/>
           <a:p>
             <a:r>
-              <a:rPr lang="en-US" smtClean="0"/>
+              <a:rPr lang="en-US"/>
               <a:t>Click to edit Master title style</a:t>
             </a:r>
-            <a:endParaRPr lang="en-US"/>
           </a:p>
         </p:txBody>
       </p:sp>
@@ -764,38 +773,37 @@
           <a:p>
             <a:pPr lvl="0"/>
             <a:r>
-              <a:rPr lang="en-US" smtClean="0"/>
+              <a:rPr lang="en-US"/>
               <a:t>Click to edit Master text styles</a:t>
             </a:r>
           </a:p>
           <a:p>
             <a:pPr lvl="1"/>
             <a:r>
-              <a:rPr lang="en-US" smtClean="0"/>
+              <a:rPr lang="en-US"/>
               <a:t>Second level</a:t>
             </a:r>
           </a:p>
           <a:p>
             <a:pPr lvl="2"/>
             <a:r>
-              <a:rPr lang="en-US" smtClean="0"/>
+              <a:rPr lang="en-US"/>
               <a:t>Third level</a:t>
             </a:r>
           </a:p>
           <a:p>
             <a:pPr lvl="3"/>
             <a:r>
-              <a:rPr lang="en-US" smtClean="0"/>
+              <a:rPr lang="en-US"/>
               <a:t>Fourth level</a:t>
             </a:r>
           </a:p>
           <a:p>
             <a:pPr lvl="4"/>
             <a:r>
-              <a:rPr lang="en-US" smtClean="0"/>
+              <a:rPr lang="en-US"/>
               <a:t>Fifth level</a:t>
             </a:r>
-            <a:endParaRPr lang="en-US"/>
           </a:p>
         </p:txBody>
       </p:sp>
@@ -816,7 +824,7 @@
           <a:p>
             <a:fld id="{5BCAD085-E8A6-8845-BD4E-CB4CCA059FC4}" type="datetimeFigureOut">
               <a:rPr lang="en-US" smtClean="0"/>
-              <a:t>1/27/13</a:t>
+              <a:t>4/8/26</a:t>
             </a:fld>
             <a:endParaRPr lang="en-US"/>
           </a:p>
@@ -919,10 +927,9 @@
           </a:lstStyle>
           <a:p>
             <a:r>
-              <a:rPr lang="en-US" smtClean="0"/>
+              <a:rPr lang="en-US"/>
               <a:t>Click to edit Master title style</a:t>
             </a:r>
-            <a:endParaRPr lang="en-US"/>
           </a:p>
         </p:txBody>
       </p:sp>
@@ -1039,7 +1046,7 @@
           <a:p>
             <a:pPr lvl="0"/>
             <a:r>
-              <a:rPr lang="en-US" smtClean="0"/>
+              <a:rPr lang="en-US"/>
               <a:t>Click to edit Master text styles</a:t>
             </a:r>
           </a:p>
@@ -1062,7 +1069,7 @@
           <a:p>
             <a:fld id="{5BCAD085-E8A6-8845-BD4E-CB4CCA059FC4}" type="datetimeFigureOut">
               <a:rPr lang="en-US" smtClean="0"/>
-              <a:t>1/27/13</a:t>
+              <a:t>4/8/26</a:t>
             </a:fld>
             <a:endParaRPr lang="en-US"/>
           </a:p>
@@ -1156,10 +1163,9 @@
           <a:lstStyle/>
           <a:p>
             <a:r>
-              <a:rPr lang="en-US" smtClean="0"/>
+              <a:rPr lang="en-US"/>
               <a:t>Click to edit Master title style</a:t>
             </a:r>
-            <a:endParaRPr lang="en-US"/>
           </a:p>
         </p:txBody>
       </p:sp>
@@ -1213,38 +1219,37 @@
           <a:p>
             <a:pPr lvl="0"/>
             <a:r>
-              <a:rPr lang="en-US" smtClean="0"/>
+              <a:rPr lang="en-US"/>
               <a:t>Click to edit Master text styles</a:t>
             </a:r>
           </a:p>
           <a:p>
             <a:pPr lvl="1"/>
             <a:r>
-              <a:rPr lang="en-US" smtClean="0"/>
+              <a:rPr lang="en-US"/>
               <a:t>Second level</a:t>
             </a:r>
           </a:p>
           <a:p>
             <a:pPr lvl="2"/>
             <a:r>
-              <a:rPr lang="en-US" smtClean="0"/>
+              <a:rPr lang="en-US"/>
               <a:t>Third level</a:t>
             </a:r>
           </a:p>
           <a:p>
             <a:pPr lvl="3"/>
             <a:r>
-              <a:rPr lang="en-US" smtClean="0"/>
+              <a:rPr lang="en-US"/>
               <a:t>Fourth level</a:t>
             </a:r>
           </a:p>
           <a:p>
             <a:pPr lvl="4"/>
             <a:r>
-              <a:rPr lang="en-US" smtClean="0"/>
+              <a:rPr lang="en-US"/>
               <a:t>Fifth level</a:t>
             </a:r>
-            <a:endParaRPr lang="en-US"/>
           </a:p>
         </p:txBody>
       </p:sp>
@@ -1298,38 +1303,37 @@
           <a:p>
             <a:pPr lvl="0"/>
             <a:r>
-              <a:rPr lang="en-US" smtClean="0"/>
+              <a:rPr lang="en-US"/>
               <a:t>Click to edit Master text styles</a:t>
             </a:r>
           </a:p>
           <a:p>
             <a:pPr lvl="1"/>
             <a:r>
-              <a:rPr lang="en-US" smtClean="0"/>
+              <a:rPr lang="en-US"/>
               <a:t>Second level</a:t>
             </a:r>
           </a:p>
           <a:p>
             <a:pPr lvl="2"/>
             <a:r>
-              <a:rPr lang="en-US" smtClean="0"/>
+              <a:rPr lang="en-US"/>
               <a:t>Third level</a:t>
             </a:r>
           </a:p>
           <a:p>
             <a:pPr lvl="3"/>
             <a:r>
-              <a:rPr lang="en-US" smtClean="0"/>
+              <a:rPr lang="en-US"/>
               <a:t>Fourth level</a:t>
             </a:r>
           </a:p>
           <a:p>
             <a:pPr lvl="4"/>
             <a:r>
-              <a:rPr lang="en-US" smtClean="0"/>
+              <a:rPr lang="en-US"/>
               <a:t>Fifth level</a:t>
             </a:r>
-            <a:endParaRPr lang="en-US"/>
           </a:p>
         </p:txBody>
       </p:sp>
@@ -1350,7 +1354,7 @@
           <a:p>
             <a:fld id="{5BCAD085-E8A6-8845-BD4E-CB4CCA059FC4}" type="datetimeFigureOut">
               <a:rPr lang="en-US" smtClean="0"/>
-              <a:t>1/27/13</a:t>
+              <a:t>4/8/26</a:t>
             </a:fld>
             <a:endParaRPr lang="en-US"/>
           </a:p>
@@ -1448,10 +1452,9 @@
           </a:lstStyle>
           <a:p>
             <a:r>
-              <a:rPr lang="en-US" smtClean="0"/>
+              <a:rPr lang="en-US"/>
               <a:t>Click to edit Master title style</a:t>
             </a:r>
-            <a:endParaRPr lang="en-US"/>
           </a:p>
         </p:txBody>
       </p:sp>
@@ -1514,7 +1517,7 @@
           <a:p>
             <a:pPr lvl="0"/>
             <a:r>
-              <a:rPr lang="en-US" smtClean="0"/>
+              <a:rPr lang="en-US"/>
               <a:t>Click to edit Master text styles</a:t>
             </a:r>
           </a:p>
@@ -1570,38 +1573,37 @@
           <a:p>
             <a:pPr lvl="0"/>
             <a:r>
-              <a:rPr lang="en-US" smtClean="0"/>
+              <a:rPr lang="en-US"/>
               <a:t>Click to edit Master text styles</a:t>
             </a:r>
           </a:p>
           <a:p>
             <a:pPr lvl="1"/>
             <a:r>
-              <a:rPr lang="en-US" smtClean="0"/>
+              <a:rPr lang="en-US"/>
               <a:t>Second level</a:t>
             </a:r>
           </a:p>
           <a:p>
             <a:pPr lvl="2"/>
             <a:r>
-              <a:rPr lang="en-US" smtClean="0"/>
+              <a:rPr lang="en-US"/>
               <a:t>Third level</a:t>
             </a:r>
           </a:p>
           <a:p>
             <a:pPr lvl="3"/>
             <a:r>
-              <a:rPr lang="en-US" smtClean="0"/>
+              <a:rPr lang="en-US"/>
               <a:t>Fourth level</a:t>
             </a:r>
           </a:p>
           <a:p>
             <a:pPr lvl="4"/>
             <a:r>
-              <a:rPr lang="en-US" smtClean="0"/>
+              <a:rPr lang="en-US"/>
               <a:t>Fifth level</a:t>
             </a:r>
-            <a:endParaRPr lang="en-US"/>
           </a:p>
         </p:txBody>
       </p:sp>
@@ -1664,7 +1666,7 @@
           <a:p>
             <a:pPr lvl="0"/>
             <a:r>
-              <a:rPr lang="en-US" smtClean="0"/>
+              <a:rPr lang="en-US"/>
               <a:t>Click to edit Master text styles</a:t>
             </a:r>
           </a:p>
@@ -1720,38 +1722,37 @@
           <a:p>
             <a:pPr lvl="0"/>
             <a:r>
-              <a:rPr lang="en-US" smtClean="0"/>
+              <a:rPr lang="en-US"/>
               <a:t>Click to edit Master text styles</a:t>
             </a:r>
           </a:p>
           <a:p>
             <a:pPr lvl="1"/>
             <a:r>
-              <a:rPr lang="en-US" smtClean="0"/>
+              <a:rPr lang="en-US"/>
               <a:t>Second level</a:t>
             </a:r>
           </a:p>
           <a:p>
             <a:pPr lvl="2"/>
             <a:r>
-              <a:rPr lang="en-US" smtClean="0"/>
+              <a:rPr lang="en-US"/>
               <a:t>Third level</a:t>
             </a:r>
           </a:p>
           <a:p>
             <a:pPr lvl="3"/>
             <a:r>
-              <a:rPr lang="en-US" smtClean="0"/>
+              <a:rPr lang="en-US"/>
               <a:t>Fourth level</a:t>
             </a:r>
           </a:p>
           <a:p>
             <a:pPr lvl="4"/>
             <a:r>
-              <a:rPr lang="en-US" smtClean="0"/>
+              <a:rPr lang="en-US"/>
               <a:t>Fifth level</a:t>
             </a:r>
-            <a:endParaRPr lang="en-US"/>
           </a:p>
         </p:txBody>
       </p:sp>
@@ -1772,7 +1773,7 @@
           <a:p>
             <a:fld id="{5BCAD085-E8A6-8845-BD4E-CB4CCA059FC4}" type="datetimeFigureOut">
               <a:rPr lang="en-US" smtClean="0"/>
-              <a:t>1/27/13</a:t>
+              <a:t>4/8/26</a:t>
             </a:fld>
             <a:endParaRPr lang="en-US"/>
           </a:p>
@@ -1866,10 +1867,9 @@
           <a:lstStyle/>
           <a:p>
             <a:r>
-              <a:rPr lang="en-US" smtClean="0"/>
+              <a:rPr lang="en-US"/>
               <a:t>Click to edit Master title style</a:t>
             </a:r>
-            <a:endParaRPr lang="en-US"/>
           </a:p>
         </p:txBody>
       </p:sp>
@@ -1890,7 +1890,7 @@
           <a:p>
             <a:fld id="{5BCAD085-E8A6-8845-BD4E-CB4CCA059FC4}" type="datetimeFigureOut">
               <a:rPr lang="en-US" smtClean="0"/>
-              <a:t>1/27/13</a:t>
+              <a:t>4/8/26</a:t>
             </a:fld>
             <a:endParaRPr lang="en-US"/>
           </a:p>
@@ -1985,7 +1985,7 @@
           <a:p>
             <a:fld id="{5BCAD085-E8A6-8845-BD4E-CB4CCA059FC4}" type="datetimeFigureOut">
               <a:rPr lang="en-US" smtClean="0"/>
-              <a:t>1/27/13</a:t>
+              <a:t>4/8/26</a:t>
             </a:fld>
             <a:endParaRPr lang="en-US"/>
           </a:p>
@@ -2088,10 +2088,9 @@
           </a:lstStyle>
           <a:p>
             <a:r>
-              <a:rPr lang="en-US" smtClean="0"/>
+              <a:rPr lang="en-US"/>
               <a:t>Click to edit Master title style</a:t>
             </a:r>
-            <a:endParaRPr lang="en-US"/>
           </a:p>
         </p:txBody>
       </p:sp>
@@ -2145,38 +2144,37 @@
           <a:p>
             <a:pPr lvl="0"/>
             <a:r>
-              <a:rPr lang="en-US" smtClean="0"/>
+              <a:rPr lang="en-US"/>
               <a:t>Click to edit Master text styles</a:t>
             </a:r>
           </a:p>
           <a:p>
             <a:pPr lvl="1"/>
             <a:r>
-              <a:rPr lang="en-US" smtClean="0"/>
+              <a:rPr lang="en-US"/>
               <a:t>Second level</a:t>
             </a:r>
           </a:p>
           <a:p>
             <a:pPr lvl="2"/>
             <a:r>
-              <a:rPr lang="en-US" smtClean="0"/>
+              <a:rPr lang="en-US"/>
               <a:t>Third level</a:t>
             </a:r>
           </a:p>
           <a:p>
             <a:pPr lvl="3"/>
             <a:r>
-              <a:rPr lang="en-US" smtClean="0"/>
+              <a:rPr lang="en-US"/>
               <a:t>Fourth level</a:t>
             </a:r>
           </a:p>
           <a:p>
             <a:pPr lvl="4"/>
             <a:r>
-              <a:rPr lang="en-US" smtClean="0"/>
+              <a:rPr lang="en-US"/>
               <a:t>Fifth level</a:t>
             </a:r>
-            <a:endParaRPr lang="en-US"/>
           </a:p>
         </p:txBody>
       </p:sp>
@@ -2239,7 +2237,7 @@
           <a:p>
             <a:pPr lvl="0"/>
             <a:r>
-              <a:rPr lang="en-US" smtClean="0"/>
+              <a:rPr lang="en-US"/>
               <a:t>Click to edit Master text styles</a:t>
             </a:r>
           </a:p>
@@ -2262,7 +2260,7 @@
           <a:p>
             <a:fld id="{5BCAD085-E8A6-8845-BD4E-CB4CCA059FC4}" type="datetimeFigureOut">
               <a:rPr lang="en-US" smtClean="0"/>
-              <a:t>1/27/13</a:t>
+              <a:t>4/8/26</a:t>
             </a:fld>
             <a:endParaRPr lang="en-US"/>
           </a:p>
@@ -2365,10 +2363,9 @@
           </a:lstStyle>
           <a:p>
             <a:r>
-              <a:rPr lang="en-US" smtClean="0"/>
+              <a:rPr lang="en-US"/>
               <a:t>Click to edit Master title style</a:t>
             </a:r>
-            <a:endParaRPr lang="en-US"/>
           </a:p>
         </p:txBody>
       </p:sp>
@@ -2492,7 +2489,7 @@
           <a:p>
             <a:pPr lvl="0"/>
             <a:r>
-              <a:rPr lang="en-US" smtClean="0"/>
+              <a:rPr lang="en-US"/>
               <a:t>Click to edit Master text styles</a:t>
             </a:r>
           </a:p>
@@ -2515,7 +2512,7 @@
           <a:p>
             <a:fld id="{5BCAD085-E8A6-8845-BD4E-CB4CCA059FC4}" type="datetimeFigureOut">
               <a:rPr lang="en-US" smtClean="0"/>
-              <a:t>1/27/13</a:t>
+              <a:t>4/8/26</a:t>
             </a:fld>
             <a:endParaRPr lang="en-US"/>
           </a:p>
@@ -2624,10 +2621,9 @@
           <a:lstStyle/>
           <a:p>
             <a:r>
-              <a:rPr lang="en-US" smtClean="0"/>
+              <a:rPr lang="en-US"/>
               <a:t>Click to edit Master title style</a:t>
             </a:r>
-            <a:endParaRPr lang="en-US"/>
           </a:p>
         </p:txBody>
       </p:sp>
@@ -2658,38 +2654,37 @@
           <a:p>
             <a:pPr lvl="0"/>
             <a:r>
-              <a:rPr lang="en-US" smtClean="0"/>
+              <a:rPr lang="en-US"/>
               <a:t>Click to edit Master text styles</a:t>
             </a:r>
           </a:p>
           <a:p>
             <a:pPr lvl="1"/>
             <a:r>
-              <a:rPr lang="en-US" smtClean="0"/>
+              <a:rPr lang="en-US"/>
               <a:t>Second level</a:t>
             </a:r>
           </a:p>
           <a:p>
             <a:pPr lvl="2"/>
             <a:r>
-              <a:rPr lang="en-US" smtClean="0"/>
+              <a:rPr lang="en-US"/>
               <a:t>Third level</a:t>
             </a:r>
           </a:p>
           <a:p>
             <a:pPr lvl="3"/>
             <a:r>
-              <a:rPr lang="en-US" smtClean="0"/>
+              <a:rPr lang="en-US"/>
               <a:t>Fourth level</a:t>
             </a:r>
           </a:p>
           <a:p>
             <a:pPr lvl="4"/>
             <a:r>
-              <a:rPr lang="en-US" smtClean="0"/>
+              <a:rPr lang="en-US"/>
               <a:t>Fifth level</a:t>
             </a:r>
-            <a:endParaRPr lang="en-US"/>
           </a:p>
         </p:txBody>
       </p:sp>
@@ -2728,7 +2723,7 @@
           <a:p>
             <a:fld id="{5BCAD085-E8A6-8845-BD4E-CB4CCA059FC4}" type="datetimeFigureOut">
               <a:rPr lang="en-US" smtClean="0"/>
-              <a:t>1/27/13</a:t>
+              <a:t>4/8/26</a:t>
             </a:fld>
             <a:endParaRPr lang="en-US"/>
           </a:p>
@@ -3087,7 +3082,7 @@
 </file>
 
 <file path=ppt/slides/slide1.xml><?xml version="1.0" encoding="utf-8"?>
-<p:sld xmlns:a="http://schemas.openxmlformats.org/drawingml/2006/main" xmlns:p="http://schemas.openxmlformats.org/presentationml/2006/main" xmlns:r="http://schemas.openxmlformats.org/officeDocument/2006/relationships">
+<p:sld xmlns:a="http://schemas.openxmlformats.org/drawingml/2006/main" xmlns:r="http://schemas.openxmlformats.org/officeDocument/2006/relationships" xmlns:p="http://schemas.openxmlformats.org/presentationml/2006/main">
   <p:cSld>
     <p:bg>
       <p:bgPr>
@@ -3103,7 +3098,14 @@
         <p:cNvGrpSpPr/>
         <p:nvPr/>
       </p:nvGrpSpPr>
-      <p:grpSpPr/>
+      <p:grpSpPr>
+        <a:xfrm>
+          <a:off x="0" y="0"/>
+          <a:ext cx="0" cy="0"/>
+          <a:chOff x="0" y="0"/>
+          <a:chExt cx="0" cy="0"/>
+        </a:xfrm>
+      </p:grpSpPr>
       <p:sp>
         <p:nvSpPr>
           <p:cNvPr id="2" name="Rectangle 1"/>
@@ -3144,6 +3146,7 @@
           <a:lstStyle/>
           <a:p>
             <a:pPr algn="ctr"/>
+            <a:endParaRPr/>
           </a:p>
         </p:txBody>
       </p:sp>
@@ -3259,6 +3262,7 @@
           <a:lstStyle/>
           <a:p>
             <a:pPr algn="ctr"/>
+            <a:endParaRPr/>
           </a:p>
         </p:txBody>
       </p:sp>
@@ -3307,7 +3311,7 @@
 </file>
 
 <file path=ppt/slides/slide2.xml><?xml version="1.0" encoding="utf-8"?>
-<p:sld xmlns:a="http://schemas.openxmlformats.org/drawingml/2006/main" xmlns:p="http://schemas.openxmlformats.org/presentationml/2006/main" xmlns:r="http://schemas.openxmlformats.org/officeDocument/2006/relationships">
+<p:sld xmlns:a="http://schemas.openxmlformats.org/drawingml/2006/main" xmlns:r="http://schemas.openxmlformats.org/officeDocument/2006/relationships" xmlns:p="http://schemas.openxmlformats.org/presentationml/2006/main">
   <p:cSld>
     <p:bg>
       <p:bgPr>
@@ -3323,7 +3327,14 @@
         <p:cNvGrpSpPr/>
         <p:nvPr/>
       </p:nvGrpSpPr>
-      <p:grpSpPr/>
+      <p:grpSpPr>
+        <a:xfrm>
+          <a:off x="0" y="0"/>
+          <a:ext cx="0" cy="0"/>
+          <a:chOff x="0" y="0"/>
+          <a:chExt cx="0" cy="0"/>
+        </a:xfrm>
+      </p:grpSpPr>
       <p:sp>
         <p:nvSpPr>
           <p:cNvPr id="2" name="Rectangle 1"/>
@@ -3364,6 +3375,7 @@
           <a:lstStyle/>
           <a:p>
             <a:pPr algn="ctr"/>
+            <a:endParaRPr/>
           </a:p>
         </p:txBody>
       </p:sp>
@@ -3444,6 +3456,7 @@
           <a:lstStyle/>
           <a:p>
             <a:pPr algn="ctr"/>
+            <a:endParaRPr/>
           </a:p>
         </p:txBody>
       </p:sp>
@@ -3577,6 +3590,7 @@
           <a:lstStyle/>
           <a:p>
             <a:pPr algn="ctr"/>
+            <a:endParaRPr/>
           </a:p>
         </p:txBody>
       </p:sp>
@@ -3710,6 +3724,7 @@
           <a:lstStyle/>
           <a:p>
             <a:pPr algn="ctr"/>
+            <a:endParaRPr/>
           </a:p>
         </p:txBody>
       </p:sp>
@@ -3811,7 +3826,7 @@
 </file>
 
 <file path=ppt/slides/slide3.xml><?xml version="1.0" encoding="utf-8"?>
-<p:sld xmlns:a="http://schemas.openxmlformats.org/drawingml/2006/main" xmlns:p="http://schemas.openxmlformats.org/presentationml/2006/main" xmlns:r="http://schemas.openxmlformats.org/officeDocument/2006/relationships">
+<p:sld xmlns:a="http://schemas.openxmlformats.org/drawingml/2006/main" xmlns:r="http://schemas.openxmlformats.org/officeDocument/2006/relationships" xmlns:p="http://schemas.openxmlformats.org/presentationml/2006/main">
   <p:cSld>
     <p:bg>
       <p:bgPr>
@@ -3827,7 +3842,14 @@
         <p:cNvGrpSpPr/>
         <p:nvPr/>
       </p:nvGrpSpPr>
-      <p:grpSpPr/>
+      <p:grpSpPr>
+        <a:xfrm>
+          <a:off x="0" y="0"/>
+          <a:ext cx="0" cy="0"/>
+          <a:chOff x="0" y="0"/>
+          <a:chExt cx="0" cy="0"/>
+        </a:xfrm>
+      </p:grpSpPr>
       <p:sp>
         <p:nvSpPr>
           <p:cNvPr id="2" name="Rectangle 1"/>
@@ -3868,6 +3890,7 @@
           <a:lstStyle/>
           <a:p>
             <a:pPr algn="ctr"/>
+            <a:endParaRPr/>
           </a:p>
         </p:txBody>
       </p:sp>
@@ -3947,6 +3970,7 @@
           <a:lstStyle/>
           <a:p>
             <a:pPr algn="ctr"/>
+            <a:endParaRPr/>
           </a:p>
         </p:txBody>
       </p:sp>
@@ -4062,6 +4086,7 @@
           <a:lstStyle/>
           <a:p>
             <a:pPr algn="ctr"/>
+            <a:endParaRPr/>
           </a:p>
         </p:txBody>
       </p:sp>
@@ -4177,6 +4202,7 @@
           <a:lstStyle/>
           <a:p>
             <a:pPr algn="ctr"/>
+            <a:endParaRPr/>
           </a:p>
         </p:txBody>
       </p:sp>
@@ -4292,6 +4318,7 @@
           <a:lstStyle/>
           <a:p>
             <a:pPr algn="ctr"/>
+            <a:endParaRPr/>
           </a:p>
         </p:txBody>
       </p:sp>
@@ -4376,7 +4403,7 @@
 </file>
 
 <file path=ppt/slides/slide4.xml><?xml version="1.0" encoding="utf-8"?>
-<p:sld xmlns:a="http://schemas.openxmlformats.org/drawingml/2006/main" xmlns:p="http://schemas.openxmlformats.org/presentationml/2006/main" xmlns:r="http://schemas.openxmlformats.org/officeDocument/2006/relationships">
+<p:sld xmlns:a="http://schemas.openxmlformats.org/drawingml/2006/main" xmlns:r="http://schemas.openxmlformats.org/officeDocument/2006/relationships" xmlns:p="http://schemas.openxmlformats.org/presentationml/2006/main">
   <p:cSld>
     <p:bg>
       <p:bgPr>
@@ -4392,7 +4419,14 @@
         <p:cNvGrpSpPr/>
         <p:nvPr/>
       </p:nvGrpSpPr>
-      <p:grpSpPr/>
+      <p:grpSpPr>
+        <a:xfrm>
+          <a:off x="0" y="0"/>
+          <a:ext cx="0" cy="0"/>
+          <a:chOff x="0" y="0"/>
+          <a:chExt cx="0" cy="0"/>
+        </a:xfrm>
+      </p:grpSpPr>
       <p:sp>
         <p:nvSpPr>
           <p:cNvPr id="2" name="Rectangle 1"/>
@@ -4433,6 +4467,7 @@
           <a:lstStyle/>
           <a:p>
             <a:pPr algn="ctr"/>
+            <a:endParaRPr/>
           </a:p>
         </p:txBody>
       </p:sp>
@@ -4512,6 +4547,7 @@
           <a:lstStyle/>
           <a:p>
             <a:pPr algn="ctr"/>
+            <a:endParaRPr/>
           </a:p>
         </p:txBody>
       </p:sp>
@@ -4648,6 +4684,7 @@
           <a:lstStyle/>
           <a:p>
             <a:pPr algn="ctr"/>
+            <a:endParaRPr/>
           </a:p>
         </p:txBody>
       </p:sp>
@@ -4793,7 +4830,7 @@
 </file>
 
 <file path=ppt/slides/slide5.xml><?xml version="1.0" encoding="utf-8"?>
-<p:sld xmlns:a="http://schemas.openxmlformats.org/drawingml/2006/main" xmlns:p="http://schemas.openxmlformats.org/presentationml/2006/main" xmlns:r="http://schemas.openxmlformats.org/officeDocument/2006/relationships">
+<p:sld xmlns:a="http://schemas.openxmlformats.org/drawingml/2006/main" xmlns:r="http://schemas.openxmlformats.org/officeDocument/2006/relationships" xmlns:p="http://schemas.openxmlformats.org/presentationml/2006/main">
   <p:cSld>
     <p:bg>
       <p:bgPr>
@@ -4809,7 +4846,14 @@
         <p:cNvGrpSpPr/>
         <p:nvPr/>
       </p:nvGrpSpPr>
-      <p:grpSpPr/>
+      <p:grpSpPr>
+        <a:xfrm>
+          <a:off x="0" y="0"/>
+          <a:ext cx="0" cy="0"/>
+          <a:chOff x="0" y="0"/>
+          <a:chExt cx="0" cy="0"/>
+        </a:xfrm>
+      </p:grpSpPr>
       <p:sp>
         <p:nvSpPr>
           <p:cNvPr id="2" name="Rectangle 1"/>
@@ -4850,6 +4894,7 @@
           <a:lstStyle/>
           <a:p>
             <a:pPr algn="ctr"/>
+            <a:endParaRPr/>
           </a:p>
         </p:txBody>
       </p:sp>
@@ -5430,7 +5475,7 @@
 </file>
 
 <file path=ppt/slides/slide6.xml><?xml version="1.0" encoding="utf-8"?>
-<p:sld xmlns:a="http://schemas.openxmlformats.org/drawingml/2006/main" xmlns:p="http://schemas.openxmlformats.org/presentationml/2006/main" xmlns:r="http://schemas.openxmlformats.org/officeDocument/2006/relationships">
+<p:sld xmlns:a="http://schemas.openxmlformats.org/drawingml/2006/main" xmlns:r="http://schemas.openxmlformats.org/officeDocument/2006/relationships" xmlns:p="http://schemas.openxmlformats.org/presentationml/2006/main">
   <p:cSld>
     <p:bg>
       <p:bgPr>
@@ -5446,7 +5491,14 @@
         <p:cNvGrpSpPr/>
         <p:nvPr/>
       </p:nvGrpSpPr>
-      <p:grpSpPr/>
+      <p:grpSpPr>
+        <a:xfrm>
+          <a:off x="0" y="0"/>
+          <a:ext cx="0" cy="0"/>
+          <a:chOff x="0" y="0"/>
+          <a:chExt cx="0" cy="0"/>
+        </a:xfrm>
+      </p:grpSpPr>
       <p:sp>
         <p:nvSpPr>
           <p:cNvPr id="2" name="Rectangle 1"/>
@@ -5487,6 +5539,7 @@
           <a:lstStyle/>
           <a:p>
             <a:pPr algn="ctr"/>
+            <a:endParaRPr/>
           </a:p>
         </p:txBody>
       </p:sp>
@@ -5962,6 +6015,7 @@
           <a:lstStyle/>
           <a:p>
             <a:pPr algn="ctr"/>
+            <a:endParaRPr/>
           </a:p>
         </p:txBody>
       </p:sp>
@@ -6056,7 +6110,7 @@
 </file>
 
 <file path=ppt/slides/slide7.xml><?xml version="1.0" encoding="utf-8"?>
-<p:sld xmlns:a="http://schemas.openxmlformats.org/drawingml/2006/main" xmlns:p="http://schemas.openxmlformats.org/presentationml/2006/main" xmlns:r="http://schemas.openxmlformats.org/officeDocument/2006/relationships">
+<p:sld xmlns:a="http://schemas.openxmlformats.org/drawingml/2006/main" xmlns:r="http://schemas.openxmlformats.org/officeDocument/2006/relationships" xmlns:p="http://schemas.openxmlformats.org/presentationml/2006/main">
   <p:cSld>
     <p:bg>
       <p:bgPr>
@@ -6072,7 +6126,14 @@
         <p:cNvGrpSpPr/>
         <p:nvPr/>
       </p:nvGrpSpPr>
-      <p:grpSpPr/>
+      <p:grpSpPr>
+        <a:xfrm>
+          <a:off x="0" y="0"/>
+          <a:ext cx="0" cy="0"/>
+          <a:chOff x="0" y="0"/>
+          <a:chExt cx="0" cy="0"/>
+        </a:xfrm>
+      </p:grpSpPr>
       <p:sp>
         <p:nvSpPr>
           <p:cNvPr id="2" name="Rectangle 1"/>
@@ -6113,6 +6174,7 @@
           <a:lstStyle/>
           <a:p>
             <a:pPr algn="ctr"/>
+            <a:endParaRPr/>
           </a:p>
         </p:txBody>
       </p:sp>
@@ -6228,6 +6290,7 @@
           <a:lstStyle/>
           <a:p>
             <a:pPr algn="ctr"/>
+            <a:endParaRPr/>
           </a:p>
         </p:txBody>
       </p:sp>
@@ -6271,6 +6334,7 @@
           <a:lstStyle/>
           <a:p>
             <a:pPr algn="ctr"/>
+            <a:endParaRPr/>
           </a:p>
         </p:txBody>
       </p:sp>
@@ -6422,6 +6486,7 @@
           <a:lstStyle/>
           <a:p>
             <a:pPr algn="ctr"/>
+            <a:endParaRPr/>
           </a:p>
         </p:txBody>
       </p:sp>
@@ -6465,6 +6530,7 @@
           <a:lstStyle/>
           <a:p>
             <a:pPr algn="ctr"/>
+            <a:endParaRPr/>
           </a:p>
         </p:txBody>
       </p:sp>
@@ -6616,6 +6682,7 @@
           <a:lstStyle/>
           <a:p>
             <a:pPr algn="ctr"/>
+            <a:endParaRPr/>
           </a:p>
         </p:txBody>
       </p:sp>
@@ -6659,6 +6726,7 @@
           <a:lstStyle/>
           <a:p>
             <a:pPr algn="ctr"/>
+            <a:endParaRPr/>
           </a:p>
         </p:txBody>
       </p:sp>
@@ -6814,7 +6882,1109 @@
 </file>
 
 <file path=ppt/slides/slide8.xml><?xml version="1.0" encoding="utf-8"?>
-<p:sld xmlns:a="http://schemas.openxmlformats.org/drawingml/2006/main" xmlns:p="http://schemas.openxmlformats.org/presentationml/2006/main" xmlns:r="http://schemas.openxmlformats.org/officeDocument/2006/relationships">
+<p:sld xmlns:a="http://schemas.openxmlformats.org/drawingml/2006/main" xmlns:r="http://schemas.openxmlformats.org/officeDocument/2006/relationships" xmlns:p="http://schemas.openxmlformats.org/presentationml/2006/main">
+  <p:cSld>
+    <p:spTree>
+      <p:nvGrpSpPr>
+        <p:cNvPr id="1" name=""/>
+        <p:cNvGrpSpPr/>
+        <p:nvPr/>
+      </p:nvGrpSpPr>
+      <p:grpSpPr>
+        <a:xfrm>
+          <a:off x="0" y="0"/>
+          <a:ext cx="0" cy="0"/>
+          <a:chOff x="0" y="0"/>
+          <a:chExt cx="0" cy="0"/>
+        </a:xfrm>
+      </p:grpSpPr>
+      <p:sp>
+        <p:nvSpPr>
+          <p:cNvPr id="2" name="Rectangle 1"/>
+          <p:cNvSpPr/>
+          <p:nvPr/>
+        </p:nvSpPr>
+        <p:spPr>
+          <a:xfrm>
+            <a:off x="0" y="0"/>
+            <a:ext cx="12191695" cy="72000"/>
+          </a:xfrm>
+          <a:prstGeom prst="rect">
+            <a:avLst/>
+          </a:prstGeom>
+          <a:solidFill>
+            <a:srgbClr val="667EEA"/>
+          </a:solidFill>
+          <a:ln>
+            <a:noFill/>
+          </a:ln>
+        </p:spPr>
+        <p:style>
+          <a:lnRef idx="1">
+            <a:schemeClr val="accent1"/>
+          </a:lnRef>
+          <a:fillRef idx="3">
+            <a:schemeClr val="accent1"/>
+          </a:fillRef>
+          <a:effectRef idx="2">
+            <a:schemeClr val="accent1"/>
+          </a:effectRef>
+          <a:fontRef idx="minor">
+            <a:schemeClr val="lt1"/>
+          </a:fontRef>
+        </p:style>
+        <p:txBody>
+          <a:bodyPr rtlCol="0" anchor="ctr"/>
+          <a:lstStyle/>
+          <a:p>
+            <a:pPr algn="ctr"/>
+            <a:endParaRPr/>
+          </a:p>
+        </p:txBody>
+      </p:sp>
+      <p:sp>
+        <p:nvSpPr>
+          <p:cNvPr id="3" name="TextBox 2"/>
+          <p:cNvSpPr txBox="1"/>
+          <p:nvPr/>
+        </p:nvSpPr>
+        <p:spPr>
+          <a:xfrm>
+            <a:off x="900000" y="432000"/>
+            <a:ext cx="10440000" cy="720000"/>
+          </a:xfrm>
+          <a:prstGeom prst="rect">
+            <a:avLst/>
+          </a:prstGeom>
+          <a:noFill/>
+        </p:spPr>
+        <p:txBody>
+          <a:bodyPr wrap="square">
+            <a:spAutoFit/>
+          </a:bodyPr>
+          <a:lstStyle/>
+          <a:p>
+            <a:pPr algn="l"/>
+            <a:r>
+              <a:rPr sz="2600" b="1">
+                <a:solidFill>
+                  <a:srgbClr val="2D2D2D"/>
+                </a:solidFill>
+                <a:latin typeface="Calibri"/>
+              </a:rPr>
+              <a:t>How We Compare to SLS Short Answer FA</a:t>
+            </a:r>
+          </a:p>
+        </p:txBody>
+      </p:sp>
+      <p:sp>
+        <p:nvSpPr>
+          <p:cNvPr id="4" name="TextBox 3"/>
+          <p:cNvSpPr txBox="1"/>
+          <p:nvPr/>
+        </p:nvSpPr>
+        <p:spPr>
+          <a:xfrm>
+            <a:off x="900000" y="1080000"/>
+            <a:ext cx="10440000" cy="360000"/>
+          </a:xfrm>
+          <a:prstGeom prst="rect">
+            <a:avLst/>
+          </a:prstGeom>
+          <a:noFill/>
+        </p:spPr>
+        <p:txBody>
+          <a:bodyPr wrap="square">
+            <a:spAutoFit/>
+          </a:bodyPr>
+          <a:lstStyle/>
+          <a:p>
+            <a:pPr algn="l"/>
+            <a:r>
+              <a:rPr sz="1200" b="0">
+                <a:solidFill>
+                  <a:srgbClr val="666666"/>
+                </a:solidFill>
+                <a:latin typeface="Calibri"/>
+              </a:rPr>
+              <a:t>Our prototype vs MOE Student Learning Space — Feedback Assistant</a:t>
+            </a:r>
+          </a:p>
+        </p:txBody>
+      </p:sp>
+      <p:sp>
+        <p:nvSpPr>
+          <p:cNvPr id="5" name="TextBox 4"/>
+          <p:cNvSpPr txBox="1"/>
+          <p:nvPr/>
+        </p:nvSpPr>
+        <p:spPr>
+          <a:xfrm>
+            <a:off x="900000" y="1512000"/>
+            <a:ext cx="4860000" cy="276999"/>
+          </a:xfrm>
+          <a:prstGeom prst="rect">
+            <a:avLst/>
+          </a:prstGeom>
+          <a:noFill/>
+        </p:spPr>
+        <p:txBody>
+          <a:bodyPr wrap="square">
+            <a:spAutoFit/>
+          </a:bodyPr>
+          <a:lstStyle/>
+          <a:p>
+            <a:pPr algn="ctr"/>
+            <a:r>
+              <a:rPr sz="1200" b="1">
+                <a:solidFill>
+                  <a:srgbClr val="667EEA"/>
+                </a:solidFill>
+                <a:latin typeface="Calibri"/>
+              </a:rPr>
+              <a:t>AI Marking Prototype</a:t>
+            </a:r>
+          </a:p>
+        </p:txBody>
+      </p:sp>
+      <p:sp>
+        <p:nvSpPr>
+          <p:cNvPr id="6" name="TextBox 5"/>
+          <p:cNvSpPr txBox="1"/>
+          <p:nvPr/>
+        </p:nvSpPr>
+        <p:spPr>
+          <a:xfrm>
+            <a:off x="900000" y="1980000"/>
+            <a:ext cx="4860000" cy="276999"/>
+          </a:xfrm>
+          <a:prstGeom prst="rect">
+            <a:avLst/>
+          </a:prstGeom>
+          <a:noFill/>
+        </p:spPr>
+        <p:txBody>
+          <a:bodyPr wrap="square">
+            <a:spAutoFit/>
+          </a:bodyPr>
+          <a:lstStyle/>
+          <a:p>
+            <a:pPr algn="l"/>
+            <a:r>
+              <a:rPr sz="1200" b="1">
+                <a:solidFill>
+                  <a:srgbClr val="28A745"/>
+                </a:solidFill>
+                <a:latin typeface="Calibri"/>
+              </a:rPr>
+              <a:t>✓  Vision-first</a:t>
+            </a:r>
+          </a:p>
+        </p:txBody>
+      </p:sp>
+      <p:sp>
+        <p:nvSpPr>
+          <p:cNvPr id="7" name="TextBox 6"/>
+          <p:cNvSpPr txBox="1"/>
+          <p:nvPr/>
+        </p:nvSpPr>
+        <p:spPr>
+          <a:xfrm>
+            <a:off x="1332000" y="2231999"/>
+            <a:ext cx="4590000" cy="276999"/>
+          </a:xfrm>
+          <a:prstGeom prst="rect">
+            <a:avLst/>
+          </a:prstGeom>
+          <a:noFill/>
+        </p:spPr>
+        <p:txBody>
+          <a:bodyPr wrap="square">
+            <a:spAutoFit/>
+          </a:bodyPr>
+          <a:lstStyle/>
+          <a:p>
+            <a:pPr algn="l"/>
+            <a:r>
+              <a:rPr sz="1200" b="0" dirty="0">
+                <a:solidFill>
+                  <a:srgbClr val="666666"/>
+                </a:solidFill>
+                <a:latin typeface="Calibri"/>
+              </a:rPr>
+              <a:t>Designed for scanned handwritten scripts — photos of physical papers</a:t>
+            </a:r>
+          </a:p>
+        </p:txBody>
+      </p:sp>
+      <p:sp>
+        <p:nvSpPr>
+          <p:cNvPr id="8" name="TextBox 7"/>
+          <p:cNvSpPr txBox="1"/>
+          <p:nvPr/>
+        </p:nvSpPr>
+        <p:spPr>
+          <a:xfrm>
+            <a:off x="900000" y="2520000"/>
+            <a:ext cx="4860000" cy="276999"/>
+          </a:xfrm>
+          <a:prstGeom prst="rect">
+            <a:avLst/>
+          </a:prstGeom>
+          <a:noFill/>
+        </p:spPr>
+        <p:txBody>
+          <a:bodyPr wrap="square">
+            <a:spAutoFit/>
+          </a:bodyPr>
+          <a:lstStyle/>
+          <a:p>
+            <a:pPr algn="l"/>
+            <a:r>
+              <a:rPr sz="1200" b="1">
+                <a:solidFill>
+                  <a:srgbClr val="28A745"/>
+                </a:solidFill>
+                <a:latin typeface="Calibri"/>
+              </a:rPr>
+              <a:t>✓  Multi-provider</a:t>
+            </a:r>
+          </a:p>
+        </p:txBody>
+      </p:sp>
+      <p:sp>
+        <p:nvSpPr>
+          <p:cNvPr id="9" name="TextBox 8"/>
+          <p:cNvSpPr txBox="1"/>
+          <p:nvPr/>
+        </p:nvSpPr>
+        <p:spPr>
+          <a:xfrm>
+            <a:off x="1332000" y="2771999"/>
+            <a:ext cx="4428000" cy="276999"/>
+          </a:xfrm>
+          <a:prstGeom prst="rect">
+            <a:avLst/>
+          </a:prstGeom>
+          <a:noFill/>
+        </p:spPr>
+        <p:txBody>
+          <a:bodyPr wrap="square">
+            <a:spAutoFit/>
+          </a:bodyPr>
+          <a:lstStyle/>
+          <a:p>
+            <a:pPr algn="l"/>
+            <a:r>
+              <a:rPr sz="1200" b="0">
+                <a:solidFill>
+                  <a:srgbClr val="666666"/>
+                </a:solidFill>
+                <a:latin typeface="Calibri"/>
+              </a:rPr>
+              <a:t>Compare Claude, GPT, Qwen side-by-side on the same script</a:t>
+            </a:r>
+          </a:p>
+        </p:txBody>
+      </p:sp>
+      <p:sp>
+        <p:nvSpPr>
+          <p:cNvPr id="10" name="TextBox 9"/>
+          <p:cNvSpPr txBox="1"/>
+          <p:nvPr/>
+        </p:nvSpPr>
+        <p:spPr>
+          <a:xfrm>
+            <a:off x="900000" y="3060000"/>
+            <a:ext cx="4860000" cy="276999"/>
+          </a:xfrm>
+          <a:prstGeom prst="rect">
+            <a:avLst/>
+          </a:prstGeom>
+          <a:noFill/>
+        </p:spPr>
+        <p:txBody>
+          <a:bodyPr wrap="square">
+            <a:spAutoFit/>
+          </a:bodyPr>
+          <a:lstStyle/>
+          <a:p>
+            <a:pPr algn="l"/>
+            <a:r>
+              <a:rPr sz="1200" b="1">
+                <a:solidFill>
+                  <a:srgbClr val="28A745"/>
+                </a:solidFill>
+                <a:latin typeface="Calibri"/>
+              </a:rPr>
+              <a:t>✓  Whole-paper marking</a:t>
+            </a:r>
+          </a:p>
+        </p:txBody>
+      </p:sp>
+      <p:sp>
+        <p:nvSpPr>
+          <p:cNvPr id="11" name="TextBox 10"/>
+          <p:cNvSpPr txBox="1"/>
+          <p:nvPr/>
+        </p:nvSpPr>
+        <p:spPr>
+          <a:xfrm>
+            <a:off x="1332000" y="3311999"/>
+            <a:ext cx="4428000" cy="276999"/>
+          </a:xfrm>
+          <a:prstGeom prst="rect">
+            <a:avLst/>
+          </a:prstGeom>
+          <a:noFill/>
+        </p:spPr>
+        <p:txBody>
+          <a:bodyPr wrap="square">
+            <a:spAutoFit/>
+          </a:bodyPr>
+          <a:lstStyle/>
+          <a:p>
+            <a:pPr algn="l"/>
+            <a:r>
+              <a:rPr sz="1200" b="0">
+                <a:solidFill>
+                  <a:srgbClr val="666666"/>
+                </a:solidFill>
+                <a:latin typeface="Calibri"/>
+              </a:rPr>
+              <a:t>Processes entire exam paper at once, not question by question</a:t>
+            </a:r>
+          </a:p>
+        </p:txBody>
+      </p:sp>
+      <p:sp>
+        <p:nvSpPr>
+          <p:cNvPr id="12" name="TextBox 11"/>
+          <p:cNvSpPr txBox="1"/>
+          <p:nvPr/>
+        </p:nvSpPr>
+        <p:spPr>
+          <a:xfrm>
+            <a:off x="900000" y="3600000"/>
+            <a:ext cx="4860000" cy="276999"/>
+          </a:xfrm>
+          <a:prstGeom prst="rect">
+            <a:avLst/>
+          </a:prstGeom>
+          <a:noFill/>
+        </p:spPr>
+        <p:txBody>
+          <a:bodyPr wrap="square">
+            <a:spAutoFit/>
+          </a:bodyPr>
+          <a:lstStyle/>
+          <a:p>
+            <a:pPr algn="l"/>
+            <a:r>
+              <a:rPr sz="1200" b="1">
+                <a:solidFill>
+                  <a:srgbClr val="28A745"/>
+                </a:solidFill>
+                <a:latin typeface="Calibri"/>
+              </a:rPr>
+              <a:t>✓  Math support</a:t>
+            </a:r>
+          </a:p>
+        </p:txBody>
+      </p:sp>
+      <p:sp>
+        <p:nvSpPr>
+          <p:cNvPr id="13" name="TextBox 12"/>
+          <p:cNvSpPr txBox="1"/>
+          <p:nvPr/>
+        </p:nvSpPr>
+        <p:spPr>
+          <a:xfrm>
+            <a:off x="1332000" y="3851999"/>
+            <a:ext cx="4428000" cy="276999"/>
+          </a:xfrm>
+          <a:prstGeom prst="rect">
+            <a:avLst/>
+          </a:prstGeom>
+          <a:noFill/>
+        </p:spPr>
+        <p:txBody>
+          <a:bodyPr wrap="square">
+            <a:spAutoFit/>
+          </a:bodyPr>
+          <a:lstStyle/>
+          <a:p>
+            <a:pPr algn="l"/>
+            <a:r>
+              <a:rPr sz="1200" b="0">
+                <a:solidFill>
+                  <a:srgbClr val="666666"/>
+                </a:solidFill>
+                <a:latin typeface="Calibri"/>
+              </a:rPr>
+              <a:t>Handles mathematical notation — SLS FA explicitly cannot</a:t>
+            </a:r>
+          </a:p>
+        </p:txBody>
+      </p:sp>
+      <p:sp>
+        <p:nvSpPr>
+          <p:cNvPr id="14" name="TextBox 13"/>
+          <p:cNvSpPr txBox="1"/>
+          <p:nvPr/>
+        </p:nvSpPr>
+        <p:spPr>
+          <a:xfrm>
+            <a:off x="900000" y="4140000"/>
+            <a:ext cx="4860000" cy="276999"/>
+          </a:xfrm>
+          <a:prstGeom prst="rect">
+            <a:avLst/>
+          </a:prstGeom>
+          <a:noFill/>
+        </p:spPr>
+        <p:txBody>
+          <a:bodyPr wrap="square">
+            <a:spAutoFit/>
+          </a:bodyPr>
+          <a:lstStyle/>
+          <a:p>
+            <a:pPr algn="l"/>
+            <a:r>
+              <a:rPr sz="1200" b="1">
+                <a:solidFill>
+                  <a:srgbClr val="28A745"/>
+                </a:solidFill>
+                <a:latin typeface="Calibri"/>
+              </a:rPr>
+              <a:t>✓  Rubrics with bands</a:t>
+            </a:r>
+          </a:p>
+        </p:txBody>
+      </p:sp>
+      <p:sp>
+        <p:nvSpPr>
+          <p:cNvPr id="15" name="TextBox 14"/>
+          <p:cNvSpPr txBox="1"/>
+          <p:nvPr/>
+        </p:nvSpPr>
+        <p:spPr>
+          <a:xfrm>
+            <a:off x="1332000" y="4391999"/>
+            <a:ext cx="4590000" cy="276999"/>
+          </a:xfrm>
+          <a:prstGeom prst="rect">
+            <a:avLst/>
+          </a:prstGeom>
+          <a:noFill/>
+        </p:spPr>
+        <p:txBody>
+          <a:bodyPr wrap="square">
+            <a:spAutoFit/>
+          </a:bodyPr>
+          <a:lstStyle/>
+          <a:p>
+            <a:pPr algn="l"/>
+            <a:r>
+              <a:rPr sz="1200" b="0" dirty="0">
+                <a:solidFill>
+                  <a:srgbClr val="666666"/>
+                </a:solidFill>
+                <a:latin typeface="Calibri"/>
+              </a:rPr>
+              <a:t>Reads rubric tables, places student in correct band, line-by-line errors</a:t>
+            </a:r>
+          </a:p>
+        </p:txBody>
+      </p:sp>
+      <p:sp>
+        <p:nvSpPr>
+          <p:cNvPr id="16" name="TextBox 15"/>
+          <p:cNvSpPr txBox="1"/>
+          <p:nvPr/>
+        </p:nvSpPr>
+        <p:spPr>
+          <a:xfrm>
+            <a:off x="900000" y="4680000"/>
+            <a:ext cx="4860000" cy="276999"/>
+          </a:xfrm>
+          <a:prstGeom prst="rect">
+            <a:avLst/>
+          </a:prstGeom>
+          <a:noFill/>
+        </p:spPr>
+        <p:txBody>
+          <a:bodyPr wrap="square">
+            <a:spAutoFit/>
+          </a:bodyPr>
+          <a:lstStyle/>
+          <a:p>
+            <a:pPr algn="l"/>
+            <a:r>
+              <a:rPr sz="1200" b="1">
+                <a:solidFill>
+                  <a:srgbClr val="28A745"/>
+                </a:solidFill>
+                <a:latin typeface="Calibri"/>
+              </a:rPr>
+              <a:t>✓  No platform lock-in</a:t>
+            </a:r>
+          </a:p>
+        </p:txBody>
+      </p:sp>
+      <p:sp>
+        <p:nvSpPr>
+          <p:cNvPr id="17" name="TextBox 16"/>
+          <p:cNvSpPr txBox="1"/>
+          <p:nvPr/>
+        </p:nvSpPr>
+        <p:spPr>
+          <a:xfrm>
+            <a:off x="1332000" y="4931999"/>
+            <a:ext cx="4428000" cy="276999"/>
+          </a:xfrm>
+          <a:prstGeom prst="rect">
+            <a:avLst/>
+          </a:prstGeom>
+          <a:noFill/>
+        </p:spPr>
+        <p:txBody>
+          <a:bodyPr wrap="square">
+            <a:spAutoFit/>
+          </a:bodyPr>
+          <a:lstStyle/>
+          <a:p>
+            <a:pPr algn="l"/>
+            <a:r>
+              <a:rPr sz="1200" b="0">
+                <a:solidFill>
+                  <a:srgbClr val="666666"/>
+                </a:solidFill>
+                <a:latin typeface="Calibri"/>
+              </a:rPr>
+              <a:t>Works independently of any LMS</a:t>
+            </a:r>
+          </a:p>
+        </p:txBody>
+      </p:sp>
+      <p:sp>
+        <p:nvSpPr>
+          <p:cNvPr id="18" name="TextBox 17"/>
+          <p:cNvSpPr txBox="1"/>
+          <p:nvPr/>
+        </p:nvSpPr>
+        <p:spPr>
+          <a:xfrm>
+            <a:off x="6300000" y="1512000"/>
+            <a:ext cx="4860000" cy="276999"/>
+          </a:xfrm>
+          <a:prstGeom prst="rect">
+            <a:avLst/>
+          </a:prstGeom>
+          <a:noFill/>
+        </p:spPr>
+        <p:txBody>
+          <a:bodyPr wrap="square">
+            <a:spAutoFit/>
+          </a:bodyPr>
+          <a:lstStyle/>
+          <a:p>
+            <a:pPr algn="ctr"/>
+            <a:r>
+              <a:rPr sz="1200" b="1">
+                <a:solidFill>
+                  <a:srgbClr val="667EEA"/>
+                </a:solidFill>
+                <a:latin typeface="Calibri"/>
+              </a:rPr>
+              <a:t>SLS Feedback Assistant</a:t>
+            </a:r>
+          </a:p>
+        </p:txBody>
+      </p:sp>
+      <p:sp>
+        <p:nvSpPr>
+          <p:cNvPr id="19" name="TextBox 18"/>
+          <p:cNvSpPr txBox="1"/>
+          <p:nvPr/>
+        </p:nvSpPr>
+        <p:spPr>
+          <a:xfrm>
+            <a:off x="6300000" y="1980000"/>
+            <a:ext cx="4860000" cy="288000"/>
+          </a:xfrm>
+          <a:prstGeom prst="rect">
+            <a:avLst/>
+          </a:prstGeom>
+          <a:noFill/>
+        </p:spPr>
+        <p:txBody>
+          <a:bodyPr wrap="square">
+            <a:spAutoFit/>
+          </a:bodyPr>
+          <a:lstStyle/>
+          <a:p>
+            <a:pPr algn="l"/>
+            <a:r>
+              <a:rPr sz="1200" b="1">
+                <a:solidFill>
+                  <a:srgbClr val="667EEA"/>
+                </a:solidFill>
+                <a:latin typeface="Calibri"/>
+              </a:rPr>
+              <a:t>✓  Integrated workflow</a:t>
+            </a:r>
+          </a:p>
+        </p:txBody>
+      </p:sp>
+      <p:sp>
+        <p:nvSpPr>
+          <p:cNvPr id="20" name="TextBox 19"/>
+          <p:cNvSpPr txBox="1"/>
+          <p:nvPr/>
+        </p:nvSpPr>
+        <p:spPr>
+          <a:xfrm>
+            <a:off x="6732000" y="2231999"/>
+            <a:ext cx="4428000" cy="276999"/>
+          </a:xfrm>
+          <a:prstGeom prst="rect">
+            <a:avLst/>
+          </a:prstGeom>
+          <a:noFill/>
+        </p:spPr>
+        <p:txBody>
+          <a:bodyPr wrap="square">
+            <a:spAutoFit/>
+          </a:bodyPr>
+          <a:lstStyle/>
+          <a:p>
+            <a:pPr algn="l"/>
+            <a:r>
+              <a:rPr sz="1200" b="0">
+                <a:solidFill>
+                  <a:srgbClr val="666666"/>
+                </a:solidFill>
+                <a:latin typeface="Calibri"/>
+              </a:rPr>
+              <a:t>Marks flow directly to students within SLS — no manual sharing</a:t>
+            </a:r>
+          </a:p>
+        </p:txBody>
+      </p:sp>
+      <p:sp>
+        <p:nvSpPr>
+          <p:cNvPr id="21" name="TextBox 20"/>
+          <p:cNvSpPr txBox="1"/>
+          <p:nvPr/>
+        </p:nvSpPr>
+        <p:spPr>
+          <a:xfrm>
+            <a:off x="6300000" y="2520000"/>
+            <a:ext cx="4860000" cy="288000"/>
+          </a:xfrm>
+          <a:prstGeom prst="rect">
+            <a:avLst/>
+          </a:prstGeom>
+          <a:noFill/>
+        </p:spPr>
+        <p:txBody>
+          <a:bodyPr wrap="square">
+            <a:spAutoFit/>
+          </a:bodyPr>
+          <a:lstStyle/>
+          <a:p>
+            <a:pPr algn="l"/>
+            <a:r>
+              <a:rPr sz="1200" b="1">
+                <a:solidFill>
+                  <a:srgbClr val="667EEA"/>
+                </a:solidFill>
+                <a:latin typeface="Calibri"/>
+              </a:rPr>
+              <a:t>✓  Class-scale</a:t>
+            </a:r>
+          </a:p>
+        </p:txBody>
+      </p:sp>
+      <p:sp>
+        <p:nvSpPr>
+          <p:cNvPr id="22" name="TextBox 21"/>
+          <p:cNvSpPr txBox="1"/>
+          <p:nvPr/>
+        </p:nvSpPr>
+        <p:spPr>
+          <a:xfrm>
+            <a:off x="6732000" y="2771999"/>
+            <a:ext cx="4428000" cy="276999"/>
+          </a:xfrm>
+          <a:prstGeom prst="rect">
+            <a:avLst/>
+          </a:prstGeom>
+          <a:noFill/>
+        </p:spPr>
+        <p:txBody>
+          <a:bodyPr wrap="square">
+            <a:spAutoFit/>
+          </a:bodyPr>
+          <a:lstStyle/>
+          <a:p>
+            <a:pPr algn="l"/>
+            <a:r>
+              <a:rPr sz="1200" b="0">
+                <a:solidFill>
+                  <a:srgbClr val="666666"/>
+                </a:solidFill>
+                <a:latin typeface="Calibri"/>
+              </a:rPr>
+              <a:t>Handles entire class rosters natively from assignment</a:t>
+            </a:r>
+          </a:p>
+        </p:txBody>
+      </p:sp>
+      <p:sp>
+        <p:nvSpPr>
+          <p:cNvPr id="23" name="TextBox 22"/>
+          <p:cNvSpPr txBox="1"/>
+          <p:nvPr/>
+        </p:nvSpPr>
+        <p:spPr>
+          <a:xfrm>
+            <a:off x="6300000" y="3060000"/>
+            <a:ext cx="4860000" cy="288000"/>
+          </a:xfrm>
+          <a:prstGeom prst="rect">
+            <a:avLst/>
+          </a:prstGeom>
+          <a:noFill/>
+        </p:spPr>
+        <p:txBody>
+          <a:bodyPr wrap="square">
+            <a:spAutoFit/>
+          </a:bodyPr>
+          <a:lstStyle/>
+          <a:p>
+            <a:pPr algn="l"/>
+            <a:r>
+              <a:rPr sz="1200" b="1">
+                <a:solidFill>
+                  <a:srgbClr val="667EEA"/>
+                </a:solidFill>
+                <a:latin typeface="Calibri"/>
+              </a:rPr>
+              <a:t>✓  Built-in rubric builder</a:t>
+            </a:r>
+          </a:p>
+        </p:txBody>
+      </p:sp>
+      <p:sp>
+        <p:nvSpPr>
+          <p:cNvPr id="24" name="TextBox 23"/>
+          <p:cNvSpPr txBox="1"/>
+          <p:nvPr/>
+        </p:nvSpPr>
+        <p:spPr>
+          <a:xfrm>
+            <a:off x="6732000" y="3311999"/>
+            <a:ext cx="4428000" cy="276999"/>
+          </a:xfrm>
+          <a:prstGeom prst="rect">
+            <a:avLst/>
+          </a:prstGeom>
+          <a:noFill/>
+        </p:spPr>
+        <p:txBody>
+          <a:bodyPr wrap="square">
+            <a:spAutoFit/>
+          </a:bodyPr>
+          <a:lstStyle/>
+          <a:p>
+            <a:pPr algn="l"/>
+            <a:r>
+              <a:rPr sz="1200" b="0">
+                <a:solidFill>
+                  <a:srgbClr val="666666"/>
+                </a:solidFill>
+                <a:latin typeface="Calibri"/>
+              </a:rPr>
+              <a:t>Create rubrics manually, from library, or AI-generated</a:t>
+            </a:r>
+          </a:p>
+        </p:txBody>
+      </p:sp>
+      <p:sp>
+        <p:nvSpPr>
+          <p:cNvPr id="25" name="TextBox 24"/>
+          <p:cNvSpPr txBox="1"/>
+          <p:nvPr/>
+        </p:nvSpPr>
+        <p:spPr>
+          <a:xfrm>
+            <a:off x="6300000" y="3600000"/>
+            <a:ext cx="4860000" cy="288000"/>
+          </a:xfrm>
+          <a:prstGeom prst="rect">
+            <a:avLst/>
+          </a:prstGeom>
+          <a:noFill/>
+        </p:spPr>
+        <p:txBody>
+          <a:bodyPr wrap="square">
+            <a:spAutoFit/>
+          </a:bodyPr>
+          <a:lstStyle/>
+          <a:p>
+            <a:pPr algn="l"/>
+            <a:r>
+              <a:rPr sz="1200" b="1">
+                <a:solidFill>
+                  <a:srgbClr val="667EEA"/>
+                </a:solidFill>
+                <a:latin typeface="Calibri"/>
+              </a:rPr>
+              <a:t>✓  Edit-in-place</a:t>
+            </a:r>
+          </a:p>
+        </p:txBody>
+      </p:sp>
+      <p:sp>
+        <p:nvSpPr>
+          <p:cNvPr id="26" name="TextBox 25"/>
+          <p:cNvSpPr txBox="1"/>
+          <p:nvPr/>
+        </p:nvSpPr>
+        <p:spPr>
+          <a:xfrm>
+            <a:off x="6732000" y="3851999"/>
+            <a:ext cx="4428000" cy="276999"/>
+          </a:xfrm>
+          <a:prstGeom prst="rect">
+            <a:avLst/>
+          </a:prstGeom>
+          <a:noFill/>
+        </p:spPr>
+        <p:txBody>
+          <a:bodyPr wrap="square">
+            <a:spAutoFit/>
+          </a:bodyPr>
+          <a:lstStyle/>
+          <a:p>
+            <a:pPr algn="l"/>
+            <a:r>
+              <a:rPr sz="1200" b="0">
+                <a:solidFill>
+                  <a:srgbClr val="666666"/>
+                </a:solidFill>
+                <a:latin typeface="Calibri"/>
+              </a:rPr>
+              <a:t>Teachers adjust marks and feedback before students see them</a:t>
+            </a:r>
+          </a:p>
+        </p:txBody>
+      </p:sp>
+      <p:sp>
+        <p:nvSpPr>
+          <p:cNvPr id="27" name="TextBox 26"/>
+          <p:cNvSpPr txBox="1"/>
+          <p:nvPr/>
+        </p:nvSpPr>
+        <p:spPr>
+          <a:xfrm>
+            <a:off x="6300000" y="4140000"/>
+            <a:ext cx="4860000" cy="288000"/>
+          </a:xfrm>
+          <a:prstGeom prst="rect">
+            <a:avLst/>
+          </a:prstGeom>
+          <a:noFill/>
+        </p:spPr>
+        <p:txBody>
+          <a:bodyPr wrap="square">
+            <a:spAutoFit/>
+          </a:bodyPr>
+          <a:lstStyle/>
+          <a:p>
+            <a:pPr algn="l"/>
+            <a:r>
+              <a:rPr sz="1200" b="1">
+                <a:solidFill>
+                  <a:srgbClr val="667EEA"/>
+                </a:solidFill>
+                <a:latin typeface="Calibri"/>
+              </a:rPr>
+              <a:t>✓  Typed responses</a:t>
+            </a:r>
+          </a:p>
+        </p:txBody>
+      </p:sp>
+      <p:sp>
+        <p:nvSpPr>
+          <p:cNvPr id="28" name="TextBox 27"/>
+          <p:cNvSpPr txBox="1"/>
+          <p:nvPr/>
+        </p:nvSpPr>
+        <p:spPr>
+          <a:xfrm>
+            <a:off x="6732000" y="4391999"/>
+            <a:ext cx="4428000" cy="276999"/>
+          </a:xfrm>
+          <a:prstGeom prst="rect">
+            <a:avLst/>
+          </a:prstGeom>
+          <a:noFill/>
+        </p:spPr>
+        <p:txBody>
+          <a:bodyPr wrap="square">
+            <a:spAutoFit/>
+          </a:bodyPr>
+          <a:lstStyle/>
+          <a:p>
+            <a:pPr algn="l"/>
+            <a:r>
+              <a:rPr sz="1200" b="0" dirty="0" err="1">
+                <a:solidFill>
+                  <a:srgbClr val="666666"/>
+                </a:solidFill>
+                <a:latin typeface="Calibri"/>
+              </a:rPr>
+              <a:t>Optimised</a:t>
+            </a:r>
+            <a:r>
+              <a:rPr sz="1200" b="0" dirty="0">
+                <a:solidFill>
+                  <a:srgbClr val="666666"/>
+                </a:solidFill>
+                <a:latin typeface="Calibri"/>
+              </a:rPr>
+              <a:t> for typed text input within the platform</a:t>
+            </a:r>
+          </a:p>
+        </p:txBody>
+      </p:sp>
+      <p:sp>
+        <p:nvSpPr>
+          <p:cNvPr id="29" name="TextBox 28"/>
+          <p:cNvSpPr txBox="1"/>
+          <p:nvPr/>
+        </p:nvSpPr>
+        <p:spPr>
+          <a:xfrm>
+            <a:off x="6300000" y="4680000"/>
+            <a:ext cx="4860000" cy="288000"/>
+          </a:xfrm>
+          <a:prstGeom prst="rect">
+            <a:avLst/>
+          </a:prstGeom>
+          <a:noFill/>
+        </p:spPr>
+        <p:txBody>
+          <a:bodyPr wrap="square">
+            <a:spAutoFit/>
+          </a:bodyPr>
+          <a:lstStyle/>
+          <a:p>
+            <a:pPr algn="l"/>
+            <a:r>
+              <a:rPr sz="1200" b="1">
+                <a:solidFill>
+                  <a:srgbClr val="667EEA"/>
+                </a:solidFill>
+                <a:latin typeface="Calibri"/>
+              </a:rPr>
+              <a:t>✓  Per-question</a:t>
+            </a:r>
+          </a:p>
+        </p:txBody>
+      </p:sp>
+      <p:sp>
+        <p:nvSpPr>
+          <p:cNvPr id="30" name="TextBox 29"/>
+          <p:cNvSpPr txBox="1"/>
+          <p:nvPr/>
+        </p:nvSpPr>
+        <p:spPr>
+          <a:xfrm>
+            <a:off x="6732000" y="4931999"/>
+            <a:ext cx="4428000" cy="276999"/>
+          </a:xfrm>
+          <a:prstGeom prst="rect">
+            <a:avLst/>
+          </a:prstGeom>
+          <a:noFill/>
+        </p:spPr>
+        <p:txBody>
+          <a:bodyPr wrap="square">
+            <a:spAutoFit/>
+          </a:bodyPr>
+          <a:lstStyle/>
+          <a:p>
+            <a:pPr algn="l"/>
+            <a:r>
+              <a:rPr sz="1200" b="0">
+                <a:solidFill>
+                  <a:srgbClr val="666666"/>
+                </a:solidFill>
+                <a:latin typeface="Calibri"/>
+              </a:rPr>
+              <a:t>Marks one question at a time with tailored mark schemes</a:t>
+            </a:r>
+          </a:p>
+        </p:txBody>
+      </p:sp>
+      <p:sp>
+        <p:nvSpPr>
+          <p:cNvPr id="31" name="Rectangle 30"/>
+          <p:cNvSpPr/>
+          <p:nvPr/>
+        </p:nvSpPr>
+        <p:spPr>
+          <a:xfrm>
+            <a:off x="5940000" y="1620000"/>
+            <a:ext cx="18000" cy="3600000"/>
+          </a:xfrm>
+          <a:prstGeom prst="rect">
+            <a:avLst/>
+          </a:prstGeom>
+          <a:solidFill>
+            <a:srgbClr val="DDDDDD"/>
+          </a:solidFill>
+          <a:ln>
+            <a:noFill/>
+          </a:ln>
+        </p:spPr>
+        <p:style>
+          <a:lnRef idx="1">
+            <a:schemeClr val="accent1"/>
+          </a:lnRef>
+          <a:fillRef idx="3">
+            <a:schemeClr val="accent1"/>
+          </a:fillRef>
+          <a:effectRef idx="2">
+            <a:schemeClr val="accent1"/>
+          </a:effectRef>
+          <a:fontRef idx="minor">
+            <a:schemeClr val="lt1"/>
+          </a:fontRef>
+        </p:style>
+        <p:txBody>
+          <a:bodyPr rtlCol="0" anchor="ctr"/>
+          <a:lstStyle/>
+          <a:p>
+            <a:pPr algn="ctr"/>
+            <a:endParaRPr sz="1200"/>
+          </a:p>
+        </p:txBody>
+      </p:sp>
+    </p:spTree>
+  </p:cSld>
+  <p:clrMapOvr>
+    <a:masterClrMapping/>
+  </p:clrMapOvr>
+</p:sld>
+</file>
+
+<file path=ppt/slides/slide9.xml><?xml version="1.0" encoding="utf-8"?>
+<p:sld xmlns:a="http://schemas.openxmlformats.org/drawingml/2006/main" xmlns:r="http://schemas.openxmlformats.org/officeDocument/2006/relationships" xmlns:p="http://schemas.openxmlformats.org/presentationml/2006/main">
   <p:cSld>
     <p:bg>
       <p:bgPr>
@@ -6830,7 +8000,14 @@
         <p:cNvGrpSpPr/>
         <p:nvPr/>
       </p:nvGrpSpPr>
-      <p:grpSpPr/>
+      <p:grpSpPr>
+        <a:xfrm>
+          <a:off x="0" y="0"/>
+          <a:ext cx="0" cy="0"/>
+          <a:chOff x="0" y="0"/>
+          <a:chExt cx="0" cy="0"/>
+        </a:xfrm>
+      </p:grpSpPr>
       <p:sp>
         <p:nvSpPr>
           <p:cNvPr id="2" name="Rectangle 1"/>
@@ -6871,6 +8048,7 @@
           <a:lstStyle/>
           <a:p>
             <a:pPr algn="ctr"/>
+            <a:endParaRPr/>
           </a:p>
         </p:txBody>
       </p:sp>
@@ -7010,6 +8188,7 @@
           <a:lstStyle/>
           <a:p>
             <a:pPr algn="ctr"/>
+            <a:endParaRPr/>
           </a:p>
         </p:txBody>
       </p:sp>
@@ -7809,6 +8988,7 @@
           <a:lstStyle/>
           <a:p>
             <a:pPr algn="ctr"/>
+            <a:endParaRPr/>
           </a:p>
         </p:txBody>
       </p:sp>
@@ -7844,1125 +9024,6 @@
             </a:pPr>
             <a:r>
               <a:t>Tip: Try the same script with different AI providers to compare marking quality!</a:t>
-            </a:r>
-          </a:p>
-        </p:txBody>
-      </p:sp>
-    </p:spTree>
-  </p:cSld>
-  <p:clrMapOvr>
-    <a:masterClrMapping/>
-  </p:clrMapOvr>
-</p:sld>
-</file>
-
-<file path=ppt/slides/slide9.xml><?xml version="1.0" encoding="utf-8"?>
-<p:sld xmlns:a="http://schemas.openxmlformats.org/drawingml/2006/main" xmlns:p="http://schemas.openxmlformats.org/presentationml/2006/main" xmlns:r="http://schemas.openxmlformats.org/officeDocument/2006/relationships">
-  <p:cSld>
-    <p:spTree>
-      <p:nvGrpSpPr>
-        <p:cNvPr id="1" name=""/>
-        <p:cNvGrpSpPr/>
-        <p:nvPr/>
-      </p:nvGrpSpPr>
-      <p:grpSpPr/>
-      <p:sp>
-        <p:nvSpPr>
-          <p:cNvPr id="2" name="Rectangle 1"/>
-          <p:cNvSpPr/>
-          <p:nvPr/>
-        </p:nvSpPr>
-        <p:spPr>
-          <a:xfrm>
-            <a:off x="0" y="0"/>
-            <a:ext cx="12191695" cy="72000"/>
-          </a:xfrm>
-          <a:prstGeom prst="rect">
-            <a:avLst/>
-          </a:prstGeom>
-          <a:solidFill>
-            <a:srgbClr val="667EEA"/>
-          </a:solidFill>
-          <a:ln>
-            <a:noFill/>
-          </a:ln>
-        </p:spPr>
-        <p:style>
-          <a:lnRef idx="1">
-            <a:schemeClr val="accent1"/>
-          </a:lnRef>
-          <a:fillRef idx="3">
-            <a:schemeClr val="accent1"/>
-          </a:fillRef>
-          <a:effectRef idx="2">
-            <a:schemeClr val="accent1"/>
-          </a:effectRef>
-          <a:fontRef idx="minor">
-            <a:schemeClr val="lt1"/>
-          </a:fontRef>
-        </p:style>
-        <p:txBody>
-          <a:bodyPr rtlCol="0" anchor="ctr"/>
-          <a:lstStyle/>
-          <a:p>
-            <a:pPr algn="ctr"/>
-          </a:p>
-        </p:txBody>
-      </p:sp>
-      <p:sp>
-        <p:nvSpPr>
-          <p:cNvPr id="3" name="TextBox 2"/>
-          <p:cNvSpPr txBox="1"/>
-          <p:nvPr/>
-        </p:nvSpPr>
-        <p:spPr>
-          <a:xfrm>
-            <a:off x="900000" y="432000"/>
-            <a:ext cx="10440000" cy="720000"/>
-          </a:xfrm>
-          <a:prstGeom prst="rect">
-            <a:avLst/>
-          </a:prstGeom>
-          <a:noFill/>
-        </p:spPr>
-        <p:txBody>
-          <a:bodyPr wrap="square">
-            <a:spAutoFit/>
-          </a:bodyPr>
-          <a:lstStyle/>
-          <a:p>
-            <a:pPr algn="l"/>
-            <a:r>
-              <a:rPr sz="2600" b="1">
-                <a:solidFill>
-                  <a:srgbClr val="2D2D2D"/>
-                </a:solidFill>
-                <a:latin typeface="Calibri"/>
-              </a:rPr>
-              <a:t>How We Compare to SLS Short Answer FA</a:t>
-            </a:r>
-          </a:p>
-        </p:txBody>
-      </p:sp>
-      <p:sp>
-        <p:nvSpPr>
-          <p:cNvPr id="4" name="TextBox 3"/>
-          <p:cNvSpPr txBox="1"/>
-          <p:nvPr/>
-        </p:nvSpPr>
-        <p:spPr>
-          <a:xfrm>
-            <a:off x="900000" y="1080000"/>
-            <a:ext cx="10440000" cy="360000"/>
-          </a:xfrm>
-          <a:prstGeom prst="rect">
-            <a:avLst/>
-          </a:prstGeom>
-          <a:noFill/>
-        </p:spPr>
-        <p:txBody>
-          <a:bodyPr wrap="square">
-            <a:spAutoFit/>
-          </a:bodyPr>
-          <a:lstStyle/>
-          <a:p>
-            <a:pPr algn="l"/>
-            <a:r>
-              <a:rPr sz="1200" b="0">
-                <a:solidFill>
-                  <a:srgbClr val="666666"/>
-                </a:solidFill>
-                <a:latin typeface="Calibri"/>
-              </a:rPr>
-              <a:t>Our prototype vs MOE Student Learning Space — Feedback Assistant</a:t>
-            </a:r>
-          </a:p>
-        </p:txBody>
-      </p:sp>
-      <p:sp>
-        <p:nvSpPr>
-          <p:cNvPr id="5" name="TextBox 4"/>
-          <p:cNvSpPr txBox="1"/>
-          <p:nvPr/>
-        </p:nvSpPr>
-        <p:spPr>
-          <a:xfrm>
-            <a:off x="900000" y="1512000"/>
-            <a:ext cx="4860000" cy="432000"/>
-          </a:xfrm>
-          <a:prstGeom prst="rect">
-            <a:avLst/>
-          </a:prstGeom>
-          <a:noFill/>
-        </p:spPr>
-        <p:txBody>
-          <a:bodyPr wrap="square">
-            <a:spAutoFit/>
-          </a:bodyPr>
-          <a:lstStyle/>
-          <a:p>
-            <a:pPr algn="ctr"/>
-            <a:r>
-              <a:rPr sz="1600" b="1">
-                <a:solidFill>
-                  <a:srgbClr val="667EEA"/>
-                </a:solidFill>
-                <a:latin typeface="Calibri"/>
-              </a:rPr>
-              <a:t>AI Marking Prototype</a:t>
-            </a:r>
-          </a:p>
-        </p:txBody>
-      </p:sp>
-      <p:sp>
-        <p:nvSpPr>
-          <p:cNvPr id="6" name="TextBox 5"/>
-          <p:cNvSpPr txBox="1"/>
-          <p:nvPr/>
-        </p:nvSpPr>
-        <p:spPr>
-          <a:xfrm>
-            <a:off x="900000" y="1980000"/>
-            <a:ext cx="4860000" cy="288000"/>
-          </a:xfrm>
-          <a:prstGeom prst="rect">
-            <a:avLst/>
-          </a:prstGeom>
-          <a:noFill/>
-        </p:spPr>
-        <p:txBody>
-          <a:bodyPr wrap="square">
-            <a:spAutoFit/>
-          </a:bodyPr>
-          <a:lstStyle/>
-          <a:p>
-            <a:pPr algn="l"/>
-            <a:r>
-              <a:rPr sz="1100" b="1">
-                <a:solidFill>
-                  <a:srgbClr val="28A745"/>
-                </a:solidFill>
-                <a:latin typeface="Calibri"/>
-              </a:rPr>
-              <a:t>✓  Vision-first</a:t>
-            </a:r>
-          </a:p>
-        </p:txBody>
-      </p:sp>
-      <p:sp>
-        <p:nvSpPr>
-          <p:cNvPr id="7" name="TextBox 6"/>
-          <p:cNvSpPr txBox="1"/>
-          <p:nvPr/>
-        </p:nvSpPr>
-        <p:spPr>
-          <a:xfrm>
-            <a:off x="1332000" y="2231999"/>
-            <a:ext cx="4428000" cy="251999"/>
-          </a:xfrm>
-          <a:prstGeom prst="rect">
-            <a:avLst/>
-          </a:prstGeom>
-          <a:noFill/>
-        </p:spPr>
-        <p:txBody>
-          <a:bodyPr wrap="square">
-            <a:spAutoFit/>
-          </a:bodyPr>
-          <a:lstStyle/>
-          <a:p>
-            <a:pPr algn="l"/>
-            <a:r>
-              <a:rPr sz="900" b="0">
-                <a:solidFill>
-                  <a:srgbClr val="666666"/>
-                </a:solidFill>
-                <a:latin typeface="Calibri"/>
-              </a:rPr>
-              <a:t>Designed for scanned handwritten scripts — photos of physical papers</a:t>
-            </a:r>
-          </a:p>
-        </p:txBody>
-      </p:sp>
-      <p:sp>
-        <p:nvSpPr>
-          <p:cNvPr id="8" name="TextBox 7"/>
-          <p:cNvSpPr txBox="1"/>
-          <p:nvPr/>
-        </p:nvSpPr>
-        <p:spPr>
-          <a:xfrm>
-            <a:off x="900000" y="2520000"/>
-            <a:ext cx="4860000" cy="288000"/>
-          </a:xfrm>
-          <a:prstGeom prst="rect">
-            <a:avLst/>
-          </a:prstGeom>
-          <a:noFill/>
-        </p:spPr>
-        <p:txBody>
-          <a:bodyPr wrap="square">
-            <a:spAutoFit/>
-          </a:bodyPr>
-          <a:lstStyle/>
-          <a:p>
-            <a:pPr algn="l"/>
-            <a:r>
-              <a:rPr sz="1100" b="1">
-                <a:solidFill>
-                  <a:srgbClr val="28A745"/>
-                </a:solidFill>
-                <a:latin typeface="Calibri"/>
-              </a:rPr>
-              <a:t>✓  Multi-provider</a:t>
-            </a:r>
-          </a:p>
-        </p:txBody>
-      </p:sp>
-      <p:sp>
-        <p:nvSpPr>
-          <p:cNvPr id="9" name="TextBox 8"/>
-          <p:cNvSpPr txBox="1"/>
-          <p:nvPr/>
-        </p:nvSpPr>
-        <p:spPr>
-          <a:xfrm>
-            <a:off x="1332000" y="2771999"/>
-            <a:ext cx="4428000" cy="251999"/>
-          </a:xfrm>
-          <a:prstGeom prst="rect">
-            <a:avLst/>
-          </a:prstGeom>
-          <a:noFill/>
-        </p:spPr>
-        <p:txBody>
-          <a:bodyPr wrap="square">
-            <a:spAutoFit/>
-          </a:bodyPr>
-          <a:lstStyle/>
-          <a:p>
-            <a:pPr algn="l"/>
-            <a:r>
-              <a:rPr sz="900" b="0">
-                <a:solidFill>
-                  <a:srgbClr val="666666"/>
-                </a:solidFill>
-                <a:latin typeface="Calibri"/>
-              </a:rPr>
-              <a:t>Compare Claude, GPT, Qwen side-by-side on the same script</a:t>
-            </a:r>
-          </a:p>
-        </p:txBody>
-      </p:sp>
-      <p:sp>
-        <p:nvSpPr>
-          <p:cNvPr id="10" name="TextBox 9"/>
-          <p:cNvSpPr txBox="1"/>
-          <p:nvPr/>
-        </p:nvSpPr>
-        <p:spPr>
-          <a:xfrm>
-            <a:off x="900000" y="3060000"/>
-            <a:ext cx="4860000" cy="288000"/>
-          </a:xfrm>
-          <a:prstGeom prst="rect">
-            <a:avLst/>
-          </a:prstGeom>
-          <a:noFill/>
-        </p:spPr>
-        <p:txBody>
-          <a:bodyPr wrap="square">
-            <a:spAutoFit/>
-          </a:bodyPr>
-          <a:lstStyle/>
-          <a:p>
-            <a:pPr algn="l"/>
-            <a:r>
-              <a:rPr sz="1100" b="1">
-                <a:solidFill>
-                  <a:srgbClr val="28A745"/>
-                </a:solidFill>
-                <a:latin typeface="Calibri"/>
-              </a:rPr>
-              <a:t>✓  Whole-paper marking</a:t>
-            </a:r>
-          </a:p>
-        </p:txBody>
-      </p:sp>
-      <p:sp>
-        <p:nvSpPr>
-          <p:cNvPr id="11" name="TextBox 10"/>
-          <p:cNvSpPr txBox="1"/>
-          <p:nvPr/>
-        </p:nvSpPr>
-        <p:spPr>
-          <a:xfrm>
-            <a:off x="1332000" y="3311999"/>
-            <a:ext cx="4428000" cy="251999"/>
-          </a:xfrm>
-          <a:prstGeom prst="rect">
-            <a:avLst/>
-          </a:prstGeom>
-          <a:noFill/>
-        </p:spPr>
-        <p:txBody>
-          <a:bodyPr wrap="square">
-            <a:spAutoFit/>
-          </a:bodyPr>
-          <a:lstStyle/>
-          <a:p>
-            <a:pPr algn="l"/>
-            <a:r>
-              <a:rPr sz="900" b="0">
-                <a:solidFill>
-                  <a:srgbClr val="666666"/>
-                </a:solidFill>
-                <a:latin typeface="Calibri"/>
-              </a:rPr>
-              <a:t>Processes entire exam paper at once, not question by question</a:t>
-            </a:r>
-          </a:p>
-        </p:txBody>
-      </p:sp>
-      <p:sp>
-        <p:nvSpPr>
-          <p:cNvPr id="12" name="TextBox 11"/>
-          <p:cNvSpPr txBox="1"/>
-          <p:nvPr/>
-        </p:nvSpPr>
-        <p:spPr>
-          <a:xfrm>
-            <a:off x="900000" y="3600000"/>
-            <a:ext cx="4860000" cy="288000"/>
-          </a:xfrm>
-          <a:prstGeom prst="rect">
-            <a:avLst/>
-          </a:prstGeom>
-          <a:noFill/>
-        </p:spPr>
-        <p:txBody>
-          <a:bodyPr wrap="square">
-            <a:spAutoFit/>
-          </a:bodyPr>
-          <a:lstStyle/>
-          <a:p>
-            <a:pPr algn="l"/>
-            <a:r>
-              <a:rPr sz="1100" b="1">
-                <a:solidFill>
-                  <a:srgbClr val="28A745"/>
-                </a:solidFill>
-                <a:latin typeface="Calibri"/>
-              </a:rPr>
-              <a:t>✓  Math support</a:t>
-            </a:r>
-          </a:p>
-        </p:txBody>
-      </p:sp>
-      <p:sp>
-        <p:nvSpPr>
-          <p:cNvPr id="13" name="TextBox 12"/>
-          <p:cNvSpPr txBox="1"/>
-          <p:nvPr/>
-        </p:nvSpPr>
-        <p:spPr>
-          <a:xfrm>
-            <a:off x="1332000" y="3851999"/>
-            <a:ext cx="4428000" cy="251999"/>
-          </a:xfrm>
-          <a:prstGeom prst="rect">
-            <a:avLst/>
-          </a:prstGeom>
-          <a:noFill/>
-        </p:spPr>
-        <p:txBody>
-          <a:bodyPr wrap="square">
-            <a:spAutoFit/>
-          </a:bodyPr>
-          <a:lstStyle/>
-          <a:p>
-            <a:pPr algn="l"/>
-            <a:r>
-              <a:rPr sz="900" b="0">
-                <a:solidFill>
-                  <a:srgbClr val="666666"/>
-                </a:solidFill>
-                <a:latin typeface="Calibri"/>
-              </a:rPr>
-              <a:t>Handles mathematical notation — SLS FA explicitly cannot</a:t>
-            </a:r>
-          </a:p>
-        </p:txBody>
-      </p:sp>
-      <p:sp>
-        <p:nvSpPr>
-          <p:cNvPr id="14" name="TextBox 13"/>
-          <p:cNvSpPr txBox="1"/>
-          <p:nvPr/>
-        </p:nvSpPr>
-        <p:spPr>
-          <a:xfrm>
-            <a:off x="900000" y="4140000"/>
-            <a:ext cx="4860000" cy="288000"/>
-          </a:xfrm>
-          <a:prstGeom prst="rect">
-            <a:avLst/>
-          </a:prstGeom>
-          <a:noFill/>
-        </p:spPr>
-        <p:txBody>
-          <a:bodyPr wrap="square">
-            <a:spAutoFit/>
-          </a:bodyPr>
-          <a:lstStyle/>
-          <a:p>
-            <a:pPr algn="l"/>
-            <a:r>
-              <a:rPr sz="1100" b="1">
-                <a:solidFill>
-                  <a:srgbClr val="28A745"/>
-                </a:solidFill>
-                <a:latin typeface="Calibri"/>
-              </a:rPr>
-              <a:t>✓  Rubrics with bands</a:t>
-            </a:r>
-          </a:p>
-        </p:txBody>
-      </p:sp>
-      <p:sp>
-        <p:nvSpPr>
-          <p:cNvPr id="15" name="TextBox 14"/>
-          <p:cNvSpPr txBox="1"/>
-          <p:nvPr/>
-        </p:nvSpPr>
-        <p:spPr>
-          <a:xfrm>
-            <a:off x="1332000" y="4391999"/>
-            <a:ext cx="4428000" cy="251999"/>
-          </a:xfrm>
-          <a:prstGeom prst="rect">
-            <a:avLst/>
-          </a:prstGeom>
-          <a:noFill/>
-        </p:spPr>
-        <p:txBody>
-          <a:bodyPr wrap="square">
-            <a:spAutoFit/>
-          </a:bodyPr>
-          <a:lstStyle/>
-          <a:p>
-            <a:pPr algn="l"/>
-            <a:r>
-              <a:rPr sz="900" b="0">
-                <a:solidFill>
-                  <a:srgbClr val="666666"/>
-                </a:solidFill>
-                <a:latin typeface="Calibri"/>
-              </a:rPr>
-              <a:t>Reads rubric tables, places student in correct band, line-by-line errors</a:t>
-            </a:r>
-          </a:p>
-        </p:txBody>
-      </p:sp>
-      <p:sp>
-        <p:nvSpPr>
-          <p:cNvPr id="16" name="TextBox 15"/>
-          <p:cNvSpPr txBox="1"/>
-          <p:nvPr/>
-        </p:nvSpPr>
-        <p:spPr>
-          <a:xfrm>
-            <a:off x="900000" y="4680000"/>
-            <a:ext cx="4860000" cy="288000"/>
-          </a:xfrm>
-          <a:prstGeom prst="rect">
-            <a:avLst/>
-          </a:prstGeom>
-          <a:noFill/>
-        </p:spPr>
-        <p:txBody>
-          <a:bodyPr wrap="square">
-            <a:spAutoFit/>
-          </a:bodyPr>
-          <a:lstStyle/>
-          <a:p>
-            <a:pPr algn="l"/>
-            <a:r>
-              <a:rPr sz="1100" b="1">
-                <a:solidFill>
-                  <a:srgbClr val="28A745"/>
-                </a:solidFill>
-                <a:latin typeface="Calibri"/>
-              </a:rPr>
-              <a:t>✓  No platform lock-in</a:t>
-            </a:r>
-          </a:p>
-        </p:txBody>
-      </p:sp>
-      <p:sp>
-        <p:nvSpPr>
-          <p:cNvPr id="17" name="TextBox 16"/>
-          <p:cNvSpPr txBox="1"/>
-          <p:nvPr/>
-        </p:nvSpPr>
-        <p:spPr>
-          <a:xfrm>
-            <a:off x="1332000" y="4931999"/>
-            <a:ext cx="4428000" cy="251999"/>
-          </a:xfrm>
-          <a:prstGeom prst="rect">
-            <a:avLst/>
-          </a:prstGeom>
-          <a:noFill/>
-        </p:spPr>
-        <p:txBody>
-          <a:bodyPr wrap="square">
-            <a:spAutoFit/>
-          </a:bodyPr>
-          <a:lstStyle/>
-          <a:p>
-            <a:pPr algn="l"/>
-            <a:r>
-              <a:rPr sz="900" b="0">
-                <a:solidFill>
-                  <a:srgbClr val="666666"/>
-                </a:solidFill>
-                <a:latin typeface="Calibri"/>
-              </a:rPr>
-              <a:t>Works independently of any LMS</a:t>
-            </a:r>
-          </a:p>
-        </p:txBody>
-      </p:sp>
-      <p:sp>
-        <p:nvSpPr>
-          <p:cNvPr id="18" name="TextBox 17"/>
-          <p:cNvSpPr txBox="1"/>
-          <p:nvPr/>
-        </p:nvSpPr>
-        <p:spPr>
-          <a:xfrm>
-            <a:off x="6300000" y="1512000"/>
-            <a:ext cx="4860000" cy="432000"/>
-          </a:xfrm>
-          <a:prstGeom prst="rect">
-            <a:avLst/>
-          </a:prstGeom>
-          <a:noFill/>
-        </p:spPr>
-        <p:txBody>
-          <a:bodyPr wrap="square">
-            <a:spAutoFit/>
-          </a:bodyPr>
-          <a:lstStyle/>
-          <a:p>
-            <a:pPr algn="ctr"/>
-            <a:r>
-              <a:rPr sz="1600" b="1">
-                <a:solidFill>
-                  <a:srgbClr val="667EEA"/>
-                </a:solidFill>
-                <a:latin typeface="Calibri"/>
-              </a:rPr>
-              <a:t>SLS Feedback Assistant</a:t>
-            </a:r>
-          </a:p>
-        </p:txBody>
-      </p:sp>
-      <p:sp>
-        <p:nvSpPr>
-          <p:cNvPr id="19" name="TextBox 18"/>
-          <p:cNvSpPr txBox="1"/>
-          <p:nvPr/>
-        </p:nvSpPr>
-        <p:spPr>
-          <a:xfrm>
-            <a:off x="6300000" y="1980000"/>
-            <a:ext cx="4860000" cy="288000"/>
-          </a:xfrm>
-          <a:prstGeom prst="rect">
-            <a:avLst/>
-          </a:prstGeom>
-          <a:noFill/>
-        </p:spPr>
-        <p:txBody>
-          <a:bodyPr wrap="square">
-            <a:spAutoFit/>
-          </a:bodyPr>
-          <a:lstStyle/>
-          <a:p>
-            <a:pPr algn="l"/>
-            <a:r>
-              <a:rPr sz="1100" b="1">
-                <a:solidFill>
-                  <a:srgbClr val="667EEA"/>
-                </a:solidFill>
-                <a:latin typeface="Calibri"/>
-              </a:rPr>
-              <a:t>✓  Integrated workflow</a:t>
-            </a:r>
-          </a:p>
-        </p:txBody>
-      </p:sp>
-      <p:sp>
-        <p:nvSpPr>
-          <p:cNvPr id="20" name="TextBox 19"/>
-          <p:cNvSpPr txBox="1"/>
-          <p:nvPr/>
-        </p:nvSpPr>
-        <p:spPr>
-          <a:xfrm>
-            <a:off x="6732000" y="2231999"/>
-            <a:ext cx="4428000" cy="251999"/>
-          </a:xfrm>
-          <a:prstGeom prst="rect">
-            <a:avLst/>
-          </a:prstGeom>
-          <a:noFill/>
-        </p:spPr>
-        <p:txBody>
-          <a:bodyPr wrap="square">
-            <a:spAutoFit/>
-          </a:bodyPr>
-          <a:lstStyle/>
-          <a:p>
-            <a:pPr algn="l"/>
-            <a:r>
-              <a:rPr sz="900" b="0">
-                <a:solidFill>
-                  <a:srgbClr val="666666"/>
-                </a:solidFill>
-                <a:latin typeface="Calibri"/>
-              </a:rPr>
-              <a:t>Marks flow directly to students within SLS — no manual sharing</a:t>
-            </a:r>
-          </a:p>
-        </p:txBody>
-      </p:sp>
-      <p:sp>
-        <p:nvSpPr>
-          <p:cNvPr id="21" name="TextBox 20"/>
-          <p:cNvSpPr txBox="1"/>
-          <p:nvPr/>
-        </p:nvSpPr>
-        <p:spPr>
-          <a:xfrm>
-            <a:off x="6300000" y="2520000"/>
-            <a:ext cx="4860000" cy="288000"/>
-          </a:xfrm>
-          <a:prstGeom prst="rect">
-            <a:avLst/>
-          </a:prstGeom>
-          <a:noFill/>
-        </p:spPr>
-        <p:txBody>
-          <a:bodyPr wrap="square">
-            <a:spAutoFit/>
-          </a:bodyPr>
-          <a:lstStyle/>
-          <a:p>
-            <a:pPr algn="l"/>
-            <a:r>
-              <a:rPr sz="1100" b="1">
-                <a:solidFill>
-                  <a:srgbClr val="667EEA"/>
-                </a:solidFill>
-                <a:latin typeface="Calibri"/>
-              </a:rPr>
-              <a:t>✓  Class-scale</a:t>
-            </a:r>
-          </a:p>
-        </p:txBody>
-      </p:sp>
-      <p:sp>
-        <p:nvSpPr>
-          <p:cNvPr id="22" name="TextBox 21"/>
-          <p:cNvSpPr txBox="1"/>
-          <p:nvPr/>
-        </p:nvSpPr>
-        <p:spPr>
-          <a:xfrm>
-            <a:off x="6732000" y="2771999"/>
-            <a:ext cx="4428000" cy="251999"/>
-          </a:xfrm>
-          <a:prstGeom prst="rect">
-            <a:avLst/>
-          </a:prstGeom>
-          <a:noFill/>
-        </p:spPr>
-        <p:txBody>
-          <a:bodyPr wrap="square">
-            <a:spAutoFit/>
-          </a:bodyPr>
-          <a:lstStyle/>
-          <a:p>
-            <a:pPr algn="l"/>
-            <a:r>
-              <a:rPr sz="900" b="0">
-                <a:solidFill>
-                  <a:srgbClr val="666666"/>
-                </a:solidFill>
-                <a:latin typeface="Calibri"/>
-              </a:rPr>
-              <a:t>Handles entire class rosters natively from assignment</a:t>
-            </a:r>
-          </a:p>
-        </p:txBody>
-      </p:sp>
-      <p:sp>
-        <p:nvSpPr>
-          <p:cNvPr id="23" name="TextBox 22"/>
-          <p:cNvSpPr txBox="1"/>
-          <p:nvPr/>
-        </p:nvSpPr>
-        <p:spPr>
-          <a:xfrm>
-            <a:off x="6300000" y="3060000"/>
-            <a:ext cx="4860000" cy="288000"/>
-          </a:xfrm>
-          <a:prstGeom prst="rect">
-            <a:avLst/>
-          </a:prstGeom>
-          <a:noFill/>
-        </p:spPr>
-        <p:txBody>
-          <a:bodyPr wrap="square">
-            <a:spAutoFit/>
-          </a:bodyPr>
-          <a:lstStyle/>
-          <a:p>
-            <a:pPr algn="l"/>
-            <a:r>
-              <a:rPr sz="1100" b="1">
-                <a:solidFill>
-                  <a:srgbClr val="667EEA"/>
-                </a:solidFill>
-                <a:latin typeface="Calibri"/>
-              </a:rPr>
-              <a:t>✓  Built-in rubric builder</a:t>
-            </a:r>
-          </a:p>
-        </p:txBody>
-      </p:sp>
-      <p:sp>
-        <p:nvSpPr>
-          <p:cNvPr id="24" name="TextBox 23"/>
-          <p:cNvSpPr txBox="1"/>
-          <p:nvPr/>
-        </p:nvSpPr>
-        <p:spPr>
-          <a:xfrm>
-            <a:off x="6732000" y="3311999"/>
-            <a:ext cx="4428000" cy="251999"/>
-          </a:xfrm>
-          <a:prstGeom prst="rect">
-            <a:avLst/>
-          </a:prstGeom>
-          <a:noFill/>
-        </p:spPr>
-        <p:txBody>
-          <a:bodyPr wrap="square">
-            <a:spAutoFit/>
-          </a:bodyPr>
-          <a:lstStyle/>
-          <a:p>
-            <a:pPr algn="l"/>
-            <a:r>
-              <a:rPr sz="900" b="0">
-                <a:solidFill>
-                  <a:srgbClr val="666666"/>
-                </a:solidFill>
-                <a:latin typeface="Calibri"/>
-              </a:rPr>
-              <a:t>Create rubrics manually, from library, or AI-generated</a:t>
-            </a:r>
-          </a:p>
-        </p:txBody>
-      </p:sp>
-      <p:sp>
-        <p:nvSpPr>
-          <p:cNvPr id="25" name="TextBox 24"/>
-          <p:cNvSpPr txBox="1"/>
-          <p:nvPr/>
-        </p:nvSpPr>
-        <p:spPr>
-          <a:xfrm>
-            <a:off x="6300000" y="3600000"/>
-            <a:ext cx="4860000" cy="288000"/>
-          </a:xfrm>
-          <a:prstGeom prst="rect">
-            <a:avLst/>
-          </a:prstGeom>
-          <a:noFill/>
-        </p:spPr>
-        <p:txBody>
-          <a:bodyPr wrap="square">
-            <a:spAutoFit/>
-          </a:bodyPr>
-          <a:lstStyle/>
-          <a:p>
-            <a:pPr algn="l"/>
-            <a:r>
-              <a:rPr sz="1100" b="1">
-                <a:solidFill>
-                  <a:srgbClr val="667EEA"/>
-                </a:solidFill>
-                <a:latin typeface="Calibri"/>
-              </a:rPr>
-              <a:t>✓  Edit-in-place</a:t>
-            </a:r>
-          </a:p>
-        </p:txBody>
-      </p:sp>
-      <p:sp>
-        <p:nvSpPr>
-          <p:cNvPr id="26" name="TextBox 25"/>
-          <p:cNvSpPr txBox="1"/>
-          <p:nvPr/>
-        </p:nvSpPr>
-        <p:spPr>
-          <a:xfrm>
-            <a:off x="6732000" y="3851999"/>
-            <a:ext cx="4428000" cy="251999"/>
-          </a:xfrm>
-          <a:prstGeom prst="rect">
-            <a:avLst/>
-          </a:prstGeom>
-          <a:noFill/>
-        </p:spPr>
-        <p:txBody>
-          <a:bodyPr wrap="square">
-            <a:spAutoFit/>
-          </a:bodyPr>
-          <a:lstStyle/>
-          <a:p>
-            <a:pPr algn="l"/>
-            <a:r>
-              <a:rPr sz="900" b="0">
-                <a:solidFill>
-                  <a:srgbClr val="666666"/>
-                </a:solidFill>
-                <a:latin typeface="Calibri"/>
-              </a:rPr>
-              <a:t>Teachers adjust marks and feedback before students see them</a:t>
-            </a:r>
-          </a:p>
-        </p:txBody>
-      </p:sp>
-      <p:sp>
-        <p:nvSpPr>
-          <p:cNvPr id="27" name="TextBox 26"/>
-          <p:cNvSpPr txBox="1"/>
-          <p:nvPr/>
-        </p:nvSpPr>
-        <p:spPr>
-          <a:xfrm>
-            <a:off x="6300000" y="4140000"/>
-            <a:ext cx="4860000" cy="288000"/>
-          </a:xfrm>
-          <a:prstGeom prst="rect">
-            <a:avLst/>
-          </a:prstGeom>
-          <a:noFill/>
-        </p:spPr>
-        <p:txBody>
-          <a:bodyPr wrap="square">
-            <a:spAutoFit/>
-          </a:bodyPr>
-          <a:lstStyle/>
-          <a:p>
-            <a:pPr algn="l"/>
-            <a:r>
-              <a:rPr sz="1100" b="1">
-                <a:solidFill>
-                  <a:srgbClr val="667EEA"/>
-                </a:solidFill>
-                <a:latin typeface="Calibri"/>
-              </a:rPr>
-              <a:t>✓  Typed responses</a:t>
-            </a:r>
-          </a:p>
-        </p:txBody>
-      </p:sp>
-      <p:sp>
-        <p:nvSpPr>
-          <p:cNvPr id="28" name="TextBox 27"/>
-          <p:cNvSpPr txBox="1"/>
-          <p:nvPr/>
-        </p:nvSpPr>
-        <p:spPr>
-          <a:xfrm>
-            <a:off x="6732000" y="4391999"/>
-            <a:ext cx="4428000" cy="251999"/>
-          </a:xfrm>
-          <a:prstGeom prst="rect">
-            <a:avLst/>
-          </a:prstGeom>
-          <a:noFill/>
-        </p:spPr>
-        <p:txBody>
-          <a:bodyPr wrap="square">
-            <a:spAutoFit/>
-          </a:bodyPr>
-          <a:lstStyle/>
-          <a:p>
-            <a:pPr algn="l"/>
-            <a:r>
-              <a:rPr sz="900" b="0">
-                <a:solidFill>
-                  <a:srgbClr val="666666"/>
-                </a:solidFill>
-                <a:latin typeface="Calibri"/>
-              </a:rPr>
-              <a:t>Optimised for typed text input within the platform</a:t>
-            </a:r>
-          </a:p>
-        </p:txBody>
-      </p:sp>
-      <p:sp>
-        <p:nvSpPr>
-          <p:cNvPr id="29" name="TextBox 28"/>
-          <p:cNvSpPr txBox="1"/>
-          <p:nvPr/>
-        </p:nvSpPr>
-        <p:spPr>
-          <a:xfrm>
-            <a:off x="6300000" y="4680000"/>
-            <a:ext cx="4860000" cy="288000"/>
-          </a:xfrm>
-          <a:prstGeom prst="rect">
-            <a:avLst/>
-          </a:prstGeom>
-          <a:noFill/>
-        </p:spPr>
-        <p:txBody>
-          <a:bodyPr wrap="square">
-            <a:spAutoFit/>
-          </a:bodyPr>
-          <a:lstStyle/>
-          <a:p>
-            <a:pPr algn="l"/>
-            <a:r>
-              <a:rPr sz="1100" b="1">
-                <a:solidFill>
-                  <a:srgbClr val="667EEA"/>
-                </a:solidFill>
-                <a:latin typeface="Calibri"/>
-              </a:rPr>
-              <a:t>✓  Per-question</a:t>
-            </a:r>
-          </a:p>
-        </p:txBody>
-      </p:sp>
-      <p:sp>
-        <p:nvSpPr>
-          <p:cNvPr id="30" name="TextBox 29"/>
-          <p:cNvSpPr txBox="1"/>
-          <p:nvPr/>
-        </p:nvSpPr>
-        <p:spPr>
-          <a:xfrm>
-            <a:off x="6732000" y="4931999"/>
-            <a:ext cx="4428000" cy="251999"/>
-          </a:xfrm>
-          <a:prstGeom prst="rect">
-            <a:avLst/>
-          </a:prstGeom>
-          <a:noFill/>
-        </p:spPr>
-        <p:txBody>
-          <a:bodyPr wrap="square">
-            <a:spAutoFit/>
-          </a:bodyPr>
-          <a:lstStyle/>
-          <a:p>
-            <a:pPr algn="l"/>
-            <a:r>
-              <a:rPr sz="900" b="0">
-                <a:solidFill>
-                  <a:srgbClr val="666666"/>
-                </a:solidFill>
-                <a:latin typeface="Calibri"/>
-              </a:rPr>
-              <a:t>Marks one question at a time with tailored mark schemes</a:t>
-            </a:r>
-          </a:p>
-        </p:txBody>
-      </p:sp>
-      <p:sp>
-        <p:nvSpPr>
-          <p:cNvPr id="31" name="Rectangle 30"/>
-          <p:cNvSpPr/>
-          <p:nvPr/>
-        </p:nvSpPr>
-        <p:spPr>
-          <a:xfrm>
-            <a:off x="5940000" y="1620000"/>
-            <a:ext cx="18000" cy="3600000"/>
-          </a:xfrm>
-          <a:prstGeom prst="rect">
-            <a:avLst/>
-          </a:prstGeom>
-          <a:solidFill>
-            <a:srgbClr val="DDDDDD"/>
-          </a:solidFill>
-          <a:ln>
-            <a:noFill/>
-          </a:ln>
-        </p:spPr>
-        <p:style>
-          <a:lnRef idx="1">
-            <a:schemeClr val="accent1"/>
-          </a:lnRef>
-          <a:fillRef idx="3">
-            <a:schemeClr val="accent1"/>
-          </a:fillRef>
-          <a:effectRef idx="2">
-            <a:schemeClr val="accent1"/>
-          </a:effectRef>
-          <a:fontRef idx="minor">
-            <a:schemeClr val="lt1"/>
-          </a:fontRef>
-        </p:style>
-        <p:txBody>
-          <a:bodyPr rtlCol="0" anchor="ctr"/>
-          <a:lstStyle/>
-          <a:p>
-            <a:pPr algn="ctr"/>
-          </a:p>
-        </p:txBody>
-      </p:sp>
-      <p:sp>
-        <p:nvSpPr>
-          <p:cNvPr id="32" name="TextBox 31"/>
-          <p:cNvSpPr txBox="1"/>
-          <p:nvPr/>
-        </p:nvSpPr>
-        <p:spPr>
-          <a:xfrm>
-            <a:off x="900000" y="5580000"/>
-            <a:ext cx="10440000" cy="540000"/>
-          </a:xfrm>
-          <a:prstGeom prst="rect">
-            <a:avLst/>
-          </a:prstGeom>
-          <a:noFill/>
-        </p:spPr>
-        <p:txBody>
-          <a:bodyPr wrap="square">
-            <a:spAutoFit/>
-          </a:bodyPr>
-          <a:lstStyle/>
-          <a:p>
-            <a:pPr algn="ctr"/>
-            <a:r>
-              <a:rPr sz="1100" b="1">
-                <a:solidFill>
-                  <a:srgbClr val="2D2D2D"/>
-                </a:solidFill>
-                <a:latin typeface="Calibri"/>
-              </a:rPr>
-              <a:t>Key difference: SLS FA is not suitable for mathematical computation. Our prototype handles math, handwriting, and scanned papers natively.</a:t>
             </a:r>
           </a:p>
         </p:txBody>

</xml_diff>